<commit_message>
M-Track Batch 3: M07 Deck (Web/Workbook)
Co-Authored-By: Claude Fable 5 <noreply@anthropic.com>
</commit_message>
<xml_diff>
--- a/protected-downloads/praesentation/M07.pptx
+++ b/protected-downloads/praesentation/M07.pptx
@@ -18,6 +18,9 @@
     <p:sldId id="266" r:id="rId18"/>
     <p:sldId id="267" r:id="rId19"/>
     <p:sldId id="268" r:id="rId20"/>
+    <p:sldId id="269" r:id="rId21"/>
+    <p:sldId id="270" r:id="rId22"/>
+    <p:sldId id="271" r:id="rId23"/>
   </p:sldIdLst>
   <p:sldSz cx="12188952" cy="6858000" type="screen4x3"/>
   <p:notesSz cx="6858000" cy="9144000"/>
@@ -584,7 +587,7 @@
           <a:lstStyle/>
           <a:p>
             <a:r>
-              <a:t>Siehe Trainerhandbuch (Sektion 3) für Moderationshinweise, Timing und erwartete Teilnehmerreaktionen.</a:t>
+              <a:t>Einstieg: „Warum ist eine Zahnarztpraxis mit 500 TEUR Umsatz mehr wert als ein Handwerksbetrieb mit gleichem Umsatz?"</a:t>
             </a:r>
           </a:p>
         </p:txBody>
@@ -654,7 +657,7 @@
           <a:lstStyle/>
           <a:p>
             <a:r>
-              <a:t>Siehe Trainerhandbuch (Sektion 3) für Moderationshinweise, Timing und erwartete Teilnehmerreaktionen.</a:t>
+              <a:t>Der Berater muss die EÜR lesen können und die Honorarlogik verstehen – sonst bewertet er falsch.</a:t>
             </a:r>
           </a:p>
         </p:txBody>
@@ -724,7 +727,7 @@
           <a:lstStyle/>
           <a:p>
             <a:r>
-              <a:t>Siehe Trainerhandbuch (Sektion 3) für Moderationshinweise, Timing und erwartete Teilnehmerreaktionen.</a:t>
+              <a:t>Das XLSX-Praxisbewertungsmodell (M07) rechnet Goodwill und Substanzwert und zeigt die Kaufpreis-Ampel.</a:t>
             </a:r>
           </a:p>
         </p:txBody>
@@ -794,132 +797,7 @@
           <a:lstStyle/>
           <a:p>
             <a:r>
-              <a:t>Musterlösung (Trainer-Referenz)</a:t>
-            </a:r>
-          </a:p>
-          <a:p>
-            <a:r>
-              <a:t>Aufgabe 1 – IDW S5:</a:t>
-            </a:r>
-          </a:p>
-          <a:p>
-            <a:r>
-              <a:t>Ø Jahresüberschuss:          303.333 EUR</a:t>
-            </a:r>
-          </a:p>
-          <a:p>
-            <a:r>
-              <a:t>./. Unternehmerlohn:         130.000 EUR</a:t>
-            </a:r>
-          </a:p>
-          <a:p>
-            <a:r>
-              <a:t>= Ertrag vor Risiko:         173.333 EUR</a:t>
-            </a:r>
-          </a:p>
-          <a:p>
-            <a:r>
-              <a:t>./. Risikoabschlag 25 %:     - 43.333 EUR</a:t>
-            </a:r>
-          </a:p>
-          <a:p>
-            <a:r>
-              <a:t>= Nachhaltiger Jahresertrag: 130.000 EUR</a:t>
-            </a:r>
-          </a:p>
-          <a:p>
-            <a:r>
-              <a:t>× Kapitalisierungsfaktor 3,0:</a:t>
-            </a:r>
-          </a:p>
-          <a:p>
-            <a:r>
-              <a:t>= Goodwill (rechnerisch):    390.000 EUR</a:t>
-            </a:r>
-          </a:p>
-          <a:p>
-            <a:r>
-              <a:t>Der vereinbarte Goodwill von 220.000 EUR liegt deutlich unter dem rechnerischen Wert (Differenz: 170.000 EUR). Die Übernahme erscheint aus Käuferperspektive günstig bewertet.</a:t>
-            </a:r>
-          </a:p>
-          <a:p>
-            <a:r>
-              <a:t>Trainer-Hinweis – Vertiefungsfragen zum Gap: Dieser Unterschied von 170.000 EUR ist erklärungsbedürftig. Regen Sie folgende Diskussion an:</a:t>
-            </a:r>
-          </a:p>
-          <a:p>
-            <a:r>
-              <a:t>1. Warum akzeptiert Dr. Schmidt einen Goodwill von nur 220.000 EUR statt der rechnerischen 390.000 EUR? Mögliche Antworten: Zeitdruck beim Verkäufer (gesundheitliche Gründe), begrenzte Zahl qualifizierter Käufer in der Region, Patientenstamm-Risiko durch hohen Anteil an Stammkunden älterer Patienten, persönliche Sympathie für den Nachfolger.</a:t>
-            </a:r>
-          </a:p>
-          <a:p>
-            <a:r>
-              <a:t>2. Ist der niedrige Kaufpreis für die Bank ein Signal oder ein Vorteil? Ein Käufer, der günstig einkauft, hat einen besseren DSCR – aber: Warum wird so günstig verkauft? Hat Dr. Schmidt Informationen, die Dr. Mayer (und die Bank) nicht haben? → Asymmetrische Information ist das zentrale Risiko.</a:t>
-            </a:r>
-          </a:p>
-          <a:p>
-            <a:r>
-              <a:t>3. Was sollte die Bank zusätzlich prüfen? Laufende Regressverfahren, Abrechnungsauffälligkeiten bei der KV, Patientenstamm-Altersstruktur (wie viele Patienten sind unter 60 und bleiben der Praxis erhalten?), lokale Wettbewerbssituation (neues MVZ in der Nähe?).</a:t>
-            </a:r>
-          </a:p>
-          <a:p>
-            <a:r>
-              <a:t>Fazit: Der günstige Kaufpreis ist aus DSCR-Sicht attraktiv – rechtfertigt aber intensivere Due Diligence, nicht weniger.</a:t>
-            </a:r>
-          </a:p>
-          <a:p>
-            <a:r>
-              <a:t>Aufgabe 2 – DSCR:</a:t>
-            </a:r>
-          </a:p>
-          <a:p>
-            <a:r>
-              <a:t>380.000 EUR / 10 Jahre = 38.000 EUR Tilgung p.a.</a:t>
-            </a:r>
-          </a:p>
-          <a:p>
-            <a:r>
-              <a:t>Zinsen Anfangsjahr: 380.000 × 5,5 % = 20.900 EUR</a:t>
-            </a:r>
-          </a:p>
-          <a:p>
-            <a:r>
-              <a:t>Zinsen Endjahr: 38.000 × 5,5 % = 2.090 EUR</a:t>
-            </a:r>
-          </a:p>
-          <a:p>
-            <a:r>
-              <a:t>Ø Zinsen: (20.900 + 2.090) / 2 = 11.495 EUR p.a.</a:t>
-            </a:r>
-          </a:p>
-          <a:p>
-            <a:r>
-              <a:t>Kapitaldienst gesamt: 38.000 + 11.495 = 49.495 EUR p.a.</a:t>
-            </a:r>
-          </a:p>
-          <a:p>
-            <a:r>
-              <a:t>DSCR: 75.000 / 49.495 = 1,52</a:t>
-            </a:r>
-          </a:p>
-          <a:p>
-            <a:r>
-              <a:t>Trainer-Hinweis – Kritische Diskussion: DSCR 1,52 liegt rechnerisch über der Mindestanforderung (1,20) – aber ist er bei diesem Risikoniveau wirklich ausreichend? Folgende Argumente sprechen dafür, ihn kritisch zu hinterfragen:</a:t>
-            </a:r>
-          </a:p>
-          <a:p>
-            <a:r>
-              <a:t>1. Anlaufrisiko: Die 65 %-Patientenübernahme ist eine Prognose, kein gesicherter Wert. Historisch werden in den ersten 12 Monaten nach Übernahme teils nur 50–60 % erreicht. Sinkt die Patientenquote auf 55 %, bricht der Cashflow auf ca. 55.000 EUR – DSCR dann unter 1,20.</a:t>
-            </a:r>
-          </a:p>
-          <a:p>
-            <a:r>
-              <a:t>2. Kein Puffer für unvorhergesehene Ausgaben: Bei einer einzigen größeren Reparatur oder einem KV-Regressverfahren fehlt der Puffer.</a:t>
-            </a:r>
-          </a:p>
-          <a:p>
-            <a:r>
-              <a:t>3. Empfehlung: Tilgungsfreie Anlaufzeit (12 Monate nur Zinsen: 11.495 EUR p.a.) deutlich beantragen – reduziert den Kapitaldienst im ersten Jahr auf ca. 23 % des freien Cashflows und schafft echten Sicherheits</a:t>
+              <a:t>Tilgungsaussetzungsmodell und BU-/Risikoabsicherung als Verbundimpuls aus der Risikoanalyse.</a:t>
             </a:r>
           </a:p>
         </p:txBody>
@@ -989,7 +867,7 @@
           <a:lstStyle/>
           <a:p>
             <a:r>
-              <a:t>Siehe Trainerhandbuch (Sektion 3) für Moderationshinweise, Timing und erwartete Teilnehmerreaktionen.</a:t>
+              <a:t>Dr. Mayer: rechnerischer Goodwill 390 TEUR gegen 220 TEUR Kaufpreis – günstiger Einstieg; DSCR Ø 1,52 trägt den Kapitaldienst.</a:t>
             </a:r>
           </a:p>
         </p:txBody>
@@ -1059,7 +937,147 @@
           <a:lstStyle/>
           <a:p>
             <a:r>
-              <a:t>Siehe Trainerhandbuch (Sektion 3) für Moderationshinweise, Timing und erwartete Teilnehmerreaktionen.</a:t>
+              <a:t>Goodwill 390 vs. Kaufpreis 220 TEUR → günstig. Sicherheiten dünn – Absicherung der Person und ggf. Schwäbisch Hall für die Praxisimmobilie.</a:t>
+            </a:r>
+          </a:p>
+        </p:txBody>
+      </p:sp>
+      <p:sp>
+        <p:nvSpPr>
+          <p:cNvPr id="4" name="Slide Number Placeholder 3"/>
+          <p:cNvSpPr>
+            <a:spLocks noGrp="1"/>
+          </p:cNvSpPr>
+          <p:nvPr>
+            <p:ph type="sldNum" idx="5" sz="quarter"/>
+          </p:nvPr>
+        </p:nvSpPr>
+        <p:spPr/>
+      </p:sp>
+    </p:spTree>
+  </p:cSld>
+  <p:clrMapOvr>
+    <a:masterClrMapping/>
+  </p:clrMapOvr>
+</p:notes>
+</file>
+
+<file path=ppt/notesSlides/notesSlide8.xml><?xml version="1.0" encoding="utf-8"?>
+<p:notes xmlns:a="http://schemas.openxmlformats.org/drawingml/2006/main" xmlns:p="http://schemas.openxmlformats.org/presentationml/2006/main" xmlns:r="http://schemas.openxmlformats.org/officeDocument/2006/relationships">
+  <p:cSld>
+    <p:spTree>
+      <p:nvGrpSpPr>
+        <p:cNvPr id="1" name=""/>
+        <p:cNvGrpSpPr/>
+        <p:nvPr/>
+      </p:nvGrpSpPr>
+      <p:grpSpPr>
+        <a:xfrm>
+          <a:off x="0" y="0"/>
+          <a:ext cx="0" cy="0"/>
+          <a:chOff x="0" y="0"/>
+          <a:chExt cx="0" cy="0"/>
+        </a:xfrm>
+      </p:grpSpPr>
+      <p:sp>
+        <p:nvSpPr>
+          <p:cNvPr id="2" name="Slide Image Placeholder 1"/>
+          <p:cNvSpPr>
+            <a:spLocks noGrp="1"/>
+          </p:cNvSpPr>
+          <p:nvPr>
+            <p:ph type="sldImg" idx="2"/>
+          </p:nvPr>
+        </p:nvSpPr>
+        <p:spPr/>
+      </p:sp>
+      <p:sp>
+        <p:nvSpPr>
+          <p:cNvPr id="3" name="Notes Placeholder 2"/>
+          <p:cNvSpPr>
+            <a:spLocks noGrp="1"/>
+          </p:cNvSpPr>
+          <p:nvPr>
+            <p:ph type="body" idx="3" sz="quarter"/>
+          </p:nvPr>
+        </p:nvSpPr>
+        <p:spPr/>
+        <p:txBody>
+          <a:bodyPr/>
+          <a:lstStyle/>
+          <a:p>
+            <a:r>
+              <a:t>Überleitung zum Selbstcheck.</a:t>
+            </a:r>
+          </a:p>
+        </p:txBody>
+      </p:sp>
+      <p:sp>
+        <p:nvSpPr>
+          <p:cNvPr id="4" name="Slide Number Placeholder 3"/>
+          <p:cNvSpPr>
+            <a:spLocks noGrp="1"/>
+          </p:cNvSpPr>
+          <p:nvPr>
+            <p:ph type="sldNum" idx="5" sz="quarter"/>
+          </p:nvPr>
+        </p:nvSpPr>
+        <p:spPr/>
+      </p:sp>
+    </p:spTree>
+  </p:cSld>
+  <p:clrMapOvr>
+    <a:masterClrMapping/>
+  </p:clrMapOvr>
+</p:notes>
+</file>
+
+<file path=ppt/notesSlides/notesSlide9.xml><?xml version="1.0" encoding="utf-8"?>
+<p:notes xmlns:a="http://schemas.openxmlformats.org/drawingml/2006/main" xmlns:p="http://schemas.openxmlformats.org/presentationml/2006/main" xmlns:r="http://schemas.openxmlformats.org/officeDocument/2006/relationships">
+  <p:cSld>
+    <p:spTree>
+      <p:nvGrpSpPr>
+        <p:cNvPr id="1" name=""/>
+        <p:cNvGrpSpPr/>
+        <p:nvPr/>
+      </p:nvGrpSpPr>
+      <p:grpSpPr>
+        <a:xfrm>
+          <a:off x="0" y="0"/>
+          <a:ext cx="0" cy="0"/>
+          <a:chOff x="0" y="0"/>
+          <a:chExt cx="0" cy="0"/>
+        </a:xfrm>
+      </p:grpSpPr>
+      <p:sp>
+        <p:nvSpPr>
+          <p:cNvPr id="2" name="Slide Image Placeholder 1"/>
+          <p:cNvSpPr>
+            <a:spLocks noGrp="1"/>
+          </p:cNvSpPr>
+          <p:nvPr>
+            <p:ph type="sldImg" idx="2"/>
+          </p:nvPr>
+        </p:nvSpPr>
+        <p:spPr/>
+      </p:sp>
+      <p:sp>
+        <p:nvSpPr>
+          <p:cNvPr id="3" name="Notes Placeholder 2"/>
+          <p:cNvSpPr>
+            <a:spLocks noGrp="1"/>
+          </p:cNvSpPr>
+          <p:nvPr>
+            <p:ph type="body" idx="3" sz="quarter"/>
+          </p:nvPr>
+        </p:nvSpPr>
+        <p:spPr/>
+        <p:txBody>
+          <a:bodyPr/>
+          <a:lstStyle/>
+          <a:p>
+            <a:r>
+              <a:t>Selbstcheck als Transferanker.</a:t>
             </a:r>
           </a:p>
         </p:txBody>
@@ -4877,7 +4895,7 @@
                 </a:solidFill>
                 <a:latin typeface="Arial"/>
               </a:rPr>
-              <a:t>Praxiscase: Dr. Mayer – Zahnarztpraxis-Übernahme in Ravensburg</a:t>
+              <a:t>Risikoprofil und Sicherheitenkonzept</a:t>
             </a:r>
           </a:p>
         </p:txBody>
@@ -4899,27 +4917,27 @@
           <a:noFill/>
         </p:spPr>
         <p:txBody>
-          <a:bodyPr wrap="square">
+          <a:bodyPr wrap="square" anchor="ctr">
             <a:spAutoFit/>
           </a:bodyPr>
           <a:lstStyle/>
           <a:p>
-            <a:pPr>
+            <a:pPr marL="177800" indent="-177800">
               <a:spcBef>
-                <a:spcPts val="1000"/>
+                <a:spcPts val="600"/>
               </a:spcBef>
               <a:spcAft>
                 <a:spcPts val="200"/>
               </a:spcAft>
             </a:pPr>
             <a:r>
-              <a:rPr sz="800" b="1">
-                <a:solidFill>
-                  <a:srgbClr val="78808C"/>
-                </a:solidFill>
-                <a:latin typeface="Consolas"/>
-              </a:rPr>
-              <a:t>AUSGANGSSITUATION</a:t>
+              <a:rPr sz="1200" i="1">
+                <a:solidFill>
+                  <a:srgbClr val="3D5466"/>
+                </a:solidFill>
+                <a:latin typeface="Arial"/>
+              </a:rPr>
+              <a:t>→  Bei Heilberufen ist die Person die Sicherheit – der Ausfall des Praxisinhabers ist das zentrale Risiko.</a:t>
             </a:r>
           </a:p>
           <a:p>
@@ -4938,7 +4956,7 @@
                 </a:solidFill>
                 <a:latin typeface="Arial"/>
               </a:rPr>
-              <a:t>▸  Kaufpreisverhandlung:</a:t>
+              <a:t>▸  Spezifische Risiken: Personenabhängigkeit, Zulassungsrecht, Honorarentwicklung.</a:t>
             </a:r>
           </a:p>
           <a:p>
@@ -4957,178 +4975,7 @@
                 </a:solidFill>
                 <a:latin typeface="Arial"/>
               </a:rPr>
-              <a:t>▸  Substanzwert (Einrichtung, Geräte): 160.000 EUR</a:t>
-            </a:r>
-          </a:p>
-          <a:p>
-            <a:pPr marL="190500" indent="-190500">
-              <a:spcBef>
-                <a:spcPts val="400"/>
-              </a:spcBef>
-              <a:spcAft>
-                <a:spcPts val="200"/>
-              </a:spcAft>
-            </a:pPr>
-            <a:r>
-              <a:rPr sz="1300">
-                <a:solidFill>
-                  <a:srgbClr val="3D5466"/>
-                </a:solidFill>
-                <a:latin typeface="Arial"/>
-              </a:rPr>
-              <a:t>▸  Goodwill (vereinbart, auf Basis IDW S5): 220.000 EUR</a:t>
-            </a:r>
-          </a:p>
-          <a:p>
-            <a:pPr marL="190500" indent="-190500">
-              <a:spcBef>
-                <a:spcPts val="400"/>
-              </a:spcBef>
-              <a:spcAft>
-                <a:spcPts val="200"/>
-              </a:spcAft>
-            </a:pPr>
-            <a:r>
-              <a:rPr sz="1300">
-                <a:solidFill>
-                  <a:srgbClr val="3D5466"/>
-                </a:solidFill>
-                <a:latin typeface="Arial"/>
-              </a:rPr>
-              <a:t>▸  Gesamtkaufpreis: 380.000 EUR</a:t>
-            </a:r>
-          </a:p>
-          <a:p>
-            <a:pPr marL="190500" indent="-190500">
-              <a:spcBef>
-                <a:spcPts val="400"/>
-              </a:spcBef>
-              <a:spcAft>
-                <a:spcPts val="200"/>
-              </a:spcAft>
-            </a:pPr>
-            <a:r>
-              <a:rPr sz="1300">
-                <a:solidFill>
-                  <a:srgbClr val="3D5466"/>
-                </a:solidFill>
-                <a:latin typeface="Arial"/>
-              </a:rPr>
-              <a:t>▸  Finanzdaten der Praxis (letzte 3 Jahre, EÜR Dr. Schmidt):</a:t>
-            </a:r>
-          </a:p>
-          <a:p>
-            <a:pPr marL="190500" indent="-190500">
-              <a:spcBef>
-                <a:spcPts val="400"/>
-              </a:spcBef>
-              <a:spcAft>
-                <a:spcPts val="200"/>
-              </a:spcAft>
-            </a:pPr>
-            <a:r>
-              <a:rPr sz="1300">
-                <a:solidFill>
-                  <a:srgbClr val="3D5466"/>
-                </a:solidFill>
-                <a:latin typeface="Arial"/>
-              </a:rPr>
-              <a:t>▸  Durchschnittlicher Jahresüberschuss: 303.333 EUR</a:t>
-            </a:r>
-          </a:p>
-          <a:p>
-            <a:pPr marL="190500" indent="-190500">
-              <a:spcBef>
-                <a:spcPts val="400"/>
-              </a:spcBef>
-              <a:spcAft>
-                <a:spcPts val="200"/>
-              </a:spcAft>
-            </a:pPr>
-            <a:r>
-              <a:rPr sz="1300">
-                <a:solidFill>
-                  <a:srgbClr val="3D5466"/>
-                </a:solidFill>
-                <a:latin typeface="Arial"/>
-              </a:rPr>
-              <a:t>▸  Finanzierungsbedarf:</a:t>
-            </a:r>
-          </a:p>
-          <a:p>
-            <a:pPr marL="190500" indent="-190500">
-              <a:spcBef>
-                <a:spcPts val="400"/>
-              </a:spcBef>
-              <a:spcAft>
-                <a:spcPts val="200"/>
-              </a:spcAft>
-            </a:pPr>
-            <a:r>
-              <a:rPr sz="1300">
-                <a:solidFill>
-                  <a:srgbClr val="3D5466"/>
-                </a:solidFill>
-                <a:latin typeface="Arial"/>
-              </a:rPr>
-              <a:t>▸  Praxiskauf: 380.000 EUR</a:t>
-            </a:r>
-          </a:p>
-          <a:p>
-            <a:pPr marL="190500" indent="-190500">
-              <a:spcBef>
-                <a:spcPts val="400"/>
-              </a:spcBef>
-              <a:spcAft>
-                <a:spcPts val="200"/>
-              </a:spcAft>
-            </a:pPr>
-            <a:r>
-              <a:rPr sz="1300">
-                <a:solidFill>
-                  <a:srgbClr val="3D5466"/>
-                </a:solidFill>
-                <a:latin typeface="Arial"/>
-              </a:rPr>
-              <a:t>▸  Betriebsmittel (Warenlager, Anlaufkosten): 30.000 EUR</a:t>
-            </a:r>
-          </a:p>
-          <a:p>
-            <a:pPr marL="190500" indent="-190500">
-              <a:spcBef>
-                <a:spcPts val="400"/>
-              </a:spcBef>
-              <a:spcAft>
-                <a:spcPts val="200"/>
-              </a:spcAft>
-            </a:pPr>
-            <a:r>
-              <a:rPr sz="1300">
-                <a:solidFill>
-                  <a:srgbClr val="3D5466"/>
-                </a:solidFill>
-                <a:latin typeface="Arial"/>
-              </a:rPr>
-              <a:t>▸  Modernisierung Röntgenanlage: 25.000 EUR</a:t>
-            </a:r>
-          </a:p>
-          <a:p>
-            <a:pPr marL="190500" indent="-190500">
-              <a:spcBef>
-                <a:spcPts val="400"/>
-              </a:spcBef>
-              <a:spcAft>
-                <a:spcPts val="200"/>
-              </a:spcAft>
-            </a:pPr>
-            <a:r>
-              <a:rPr sz="1300">
-                <a:solidFill>
-                  <a:srgbClr val="3D5466"/>
-                </a:solidFill>
-                <a:latin typeface="Arial"/>
-              </a:rPr>
-              <a:t>▸  Gesamtbedarf: 435.000 EUR</a:t>
+              <a:t>▸  Sicherheitenkonzept oft dünn (wenig Substanz) – Verbundpartner Schwäbisch Hall für Praxisimmobilien.</a:t>
             </a:r>
           </a:p>
         </p:txBody>
@@ -5345,7 +5192,7 @@
                 </a:solidFill>
                 <a:latin typeface="Consolas"/>
               </a:rPr>
-              <a:t>M07  ·  ÜBERSICHT</a:t>
+              <a:t>M07  ·  SCHAUBILD</a:t>
             </a:r>
           </a:p>
         </p:txBody>
@@ -5380,7 +5227,605 @@
                 </a:solidFill>
                 <a:latin typeface="Arial"/>
               </a:rPr>
-              <a:t>Praxiscase: Dr. Mayer – Zahnarztpraxis-Übernahme in Ravensburg</a:t>
+              <a:t>Handlungsempfehlung: Heilberufe-Finanzierung</a:t>
+            </a:r>
+          </a:p>
+        </p:txBody>
+      </p:sp>
+      <p:sp>
+        <p:nvSpPr>
+          <p:cNvPr id="6" name="Rectangle 5"/>
+          <p:cNvSpPr/>
+          <p:nvPr/>
+        </p:nvSpPr>
+        <p:spPr>
+          <a:xfrm>
+            <a:off x="685800" y="1143000"/>
+            <a:ext cx="10817352" cy="25400"/>
+          </a:xfrm>
+          <a:prstGeom prst="rect">
+            <a:avLst/>
+          </a:prstGeom>
+          <a:solidFill>
+            <a:srgbClr val="D9C089"/>
+          </a:solidFill>
+          <a:ln>
+            <a:noFill/>
+          </a:ln>
+        </p:spPr>
+        <p:style>
+          <a:lnRef idx="1">
+            <a:schemeClr val="accent1"/>
+          </a:lnRef>
+          <a:fillRef idx="3">
+            <a:schemeClr val="accent1"/>
+          </a:fillRef>
+          <a:effectRef idx="2">
+            <a:schemeClr val="accent1"/>
+          </a:effectRef>
+          <a:fontRef idx="minor">
+            <a:schemeClr val="lt1"/>
+          </a:fontRef>
+        </p:style>
+        <p:txBody>
+          <a:bodyPr rtlCol="0" anchor="ctr"/>
+          <a:lstStyle/>
+          <a:p>
+            <a:pPr algn="ctr"/>
+          </a:p>
+        </p:txBody>
+      </p:sp>
+      <p:pic>
+        <p:nvPicPr>
+          <p:cNvPr id="7" name="Picture 6" descr="image.png"/>
+          <p:cNvPicPr>
+            <a:picLocks noChangeAspect="1"/>
+          </p:cNvPicPr>
+          <p:nvPr/>
+        </p:nvPicPr>
+        <p:blipFill>
+          <a:blip r:embed="rId2"/>
+          <a:stretch>
+            <a:fillRect/>
+          </a:stretch>
+        </p:blipFill>
+        <p:spPr>
+          <a:xfrm>
+            <a:off x="2303489" y="1325880"/>
+            <a:ext cx="7581973" cy="4937760"/>
+          </a:xfrm>
+          <a:prstGeom prst="rect">
+            <a:avLst/>
+          </a:prstGeom>
+        </p:spPr>
+      </p:pic>
+      <p:sp>
+        <p:nvSpPr>
+          <p:cNvPr id="8" name="Rectangle 7"/>
+          <p:cNvSpPr/>
+          <p:nvPr/>
+        </p:nvSpPr>
+        <p:spPr>
+          <a:xfrm>
+            <a:off x="0" y="6510528"/>
+            <a:ext cx="12188952" cy="347472"/>
+          </a:xfrm>
+          <a:prstGeom prst="rect">
+            <a:avLst/>
+          </a:prstGeom>
+          <a:solidFill>
+            <a:srgbClr val="0A1937"/>
+          </a:solidFill>
+          <a:ln>
+            <a:noFill/>
+          </a:ln>
+        </p:spPr>
+        <p:style>
+          <a:lnRef idx="1">
+            <a:schemeClr val="accent1"/>
+          </a:lnRef>
+          <a:fillRef idx="3">
+            <a:schemeClr val="accent1"/>
+          </a:fillRef>
+          <a:effectRef idx="2">
+            <a:schemeClr val="accent1"/>
+          </a:effectRef>
+          <a:fontRef idx="minor">
+            <a:schemeClr val="lt1"/>
+          </a:fontRef>
+        </p:style>
+        <p:txBody>
+          <a:bodyPr rtlCol="0" anchor="ctr"/>
+          <a:lstStyle/>
+          <a:p>
+            <a:pPr algn="ctr"/>
+          </a:p>
+        </p:txBody>
+      </p:sp>
+      <p:sp>
+        <p:nvSpPr>
+          <p:cNvPr id="9" name="TextBox 8"/>
+          <p:cNvSpPr txBox="1"/>
+          <p:nvPr/>
+        </p:nvSpPr>
+        <p:spPr>
+          <a:xfrm>
+            <a:off x="685800" y="6583680"/>
+            <a:ext cx="6490411" cy="256032"/>
+          </a:xfrm>
+          <a:prstGeom prst="rect">
+            <a:avLst/>
+          </a:prstGeom>
+          <a:noFill/>
+        </p:spPr>
+        <p:txBody>
+          <a:bodyPr wrap="none">
+            <a:spAutoFit/>
+          </a:bodyPr>
+          <a:lstStyle/>
+          <a:p>
+            <a:pPr algn="l"/>
+            <a:r>
+              <a:rPr sz="700">
+                <a:solidFill>
+                  <a:srgbClr val="A0B4D2"/>
+                </a:solidFill>
+                <a:latin typeface="Consolas"/>
+              </a:rPr>
+              <a:t>FKB Campus  ·  M07</a:t>
+            </a:r>
+          </a:p>
+        </p:txBody>
+      </p:sp>
+      <p:sp>
+        <p:nvSpPr>
+          <p:cNvPr id="10" name="TextBox 9"/>
+          <p:cNvSpPr txBox="1"/>
+          <p:nvPr/>
+        </p:nvSpPr>
+        <p:spPr>
+          <a:xfrm>
+            <a:off x="7176211" y="6583680"/>
+            <a:ext cx="4326940" cy="256032"/>
+          </a:xfrm>
+          <a:prstGeom prst="rect">
+            <a:avLst/>
+          </a:prstGeom>
+          <a:noFill/>
+        </p:spPr>
+        <p:txBody>
+          <a:bodyPr wrap="none">
+            <a:spAutoFit/>
+          </a:bodyPr>
+          <a:lstStyle/>
+          <a:p>
+            <a:pPr algn="r"/>
+            <a:r>
+              <a:rPr sz="700">
+                <a:solidFill>
+                  <a:srgbClr val="A0B4D2"/>
+                </a:solidFill>
+                <a:latin typeface="Consolas"/>
+              </a:rPr>
+              <a:t>Schaubild</a:t>
+            </a:r>
+          </a:p>
+        </p:txBody>
+      </p:sp>
+    </p:spTree>
+  </p:cSld>
+  <p:clrMapOvr>
+    <a:masterClrMapping/>
+  </p:clrMapOvr>
+</p:sld>
+</file>
+
+<file path=ppt/slides/slide12.xml><?xml version="1.0" encoding="utf-8"?>
+<p:sld xmlns:a="http://schemas.openxmlformats.org/drawingml/2006/main" xmlns:p="http://schemas.openxmlformats.org/presentationml/2006/main" xmlns:r="http://schemas.openxmlformats.org/officeDocument/2006/relationships">
+  <p:cSld>
+    <p:spTree>
+      <p:nvGrpSpPr>
+        <p:cNvPr id="1" name=""/>
+        <p:cNvGrpSpPr/>
+        <p:nvPr/>
+      </p:nvGrpSpPr>
+      <p:grpSpPr/>
+      <p:sp>
+        <p:nvSpPr>
+          <p:cNvPr id="2" name="Rectangle 1"/>
+          <p:cNvSpPr/>
+          <p:nvPr/>
+        </p:nvSpPr>
+        <p:spPr>
+          <a:xfrm>
+            <a:off x="0" y="0"/>
+            <a:ext cx="12188952" cy="6858000"/>
+          </a:xfrm>
+          <a:prstGeom prst="rect">
+            <a:avLst/>
+          </a:prstGeom>
+          <a:solidFill>
+            <a:srgbClr val="1F2C56"/>
+          </a:solidFill>
+          <a:ln>
+            <a:noFill/>
+          </a:ln>
+        </p:spPr>
+        <p:style>
+          <a:lnRef idx="1">
+            <a:schemeClr val="accent1"/>
+          </a:lnRef>
+          <a:fillRef idx="3">
+            <a:schemeClr val="accent1"/>
+          </a:fillRef>
+          <a:effectRef idx="2">
+            <a:schemeClr val="accent1"/>
+          </a:effectRef>
+          <a:fontRef idx="minor">
+            <a:schemeClr val="lt1"/>
+          </a:fontRef>
+        </p:style>
+        <p:txBody>
+          <a:bodyPr rtlCol="0" anchor="ctr"/>
+          <a:lstStyle/>
+          <a:p>
+            <a:pPr algn="ctr"/>
+          </a:p>
+        </p:txBody>
+      </p:sp>
+      <p:sp>
+        <p:nvSpPr>
+          <p:cNvPr id="3" name="TextBox 2"/>
+          <p:cNvSpPr txBox="1"/>
+          <p:nvPr/>
+        </p:nvSpPr>
+        <p:spPr>
+          <a:xfrm>
+            <a:off x="685800" y="2377440"/>
+            <a:ext cx="10817352" cy="365760"/>
+          </a:xfrm>
+          <a:prstGeom prst="rect">
+            <a:avLst/>
+          </a:prstGeom>
+          <a:noFill/>
+        </p:spPr>
+        <p:txBody>
+          <a:bodyPr wrap="none">
+            <a:spAutoFit/>
+          </a:bodyPr>
+          <a:lstStyle/>
+          <a:p>
+            <a:pPr algn="l"/>
+            <a:r>
+              <a:rPr sz="1200">
+                <a:solidFill>
+                  <a:srgbClr val="D9C089"/>
+                </a:solidFill>
+                <a:latin typeface="Consolas"/>
+              </a:rPr>
+              <a:t>FALLARBEIT</a:t>
+            </a:r>
+          </a:p>
+        </p:txBody>
+      </p:sp>
+      <p:sp>
+        <p:nvSpPr>
+          <p:cNvPr id="4" name="Rectangle 3"/>
+          <p:cNvSpPr/>
+          <p:nvPr/>
+        </p:nvSpPr>
+        <p:spPr>
+          <a:xfrm>
+            <a:off x="685800" y="2788920"/>
+            <a:ext cx="548640" cy="38100"/>
+          </a:xfrm>
+          <a:prstGeom prst="rect">
+            <a:avLst/>
+          </a:prstGeom>
+          <a:solidFill>
+            <a:srgbClr val="D9C089"/>
+          </a:solidFill>
+          <a:ln>
+            <a:noFill/>
+          </a:ln>
+        </p:spPr>
+        <p:style>
+          <a:lnRef idx="1">
+            <a:schemeClr val="accent1"/>
+          </a:lnRef>
+          <a:fillRef idx="3">
+            <a:schemeClr val="accent1"/>
+          </a:fillRef>
+          <a:effectRef idx="2">
+            <a:schemeClr val="accent1"/>
+          </a:effectRef>
+          <a:fontRef idx="minor">
+            <a:schemeClr val="lt1"/>
+          </a:fontRef>
+        </p:style>
+        <p:txBody>
+          <a:bodyPr rtlCol="0" anchor="ctr"/>
+          <a:lstStyle/>
+          <a:p>
+            <a:pPr algn="ctr"/>
+          </a:p>
+        </p:txBody>
+      </p:sp>
+      <p:sp>
+        <p:nvSpPr>
+          <p:cNvPr id="5" name="TextBox 4"/>
+          <p:cNvSpPr txBox="1"/>
+          <p:nvPr/>
+        </p:nvSpPr>
+        <p:spPr>
+          <a:xfrm>
+            <a:off x="685800" y="3017520"/>
+            <a:ext cx="10817352" cy="1463040"/>
+          </a:xfrm>
+          <a:prstGeom prst="rect">
+            <a:avLst/>
+          </a:prstGeom>
+          <a:noFill/>
+        </p:spPr>
+        <p:txBody>
+          <a:bodyPr wrap="square">
+            <a:spAutoFit/>
+          </a:bodyPr>
+          <a:lstStyle/>
+          <a:p>
+            <a:pPr algn="l"/>
+            <a:r>
+              <a:rPr sz="4000" b="1" i="0">
+                <a:solidFill>
+                  <a:srgbClr val="FFFFFF"/>
+                </a:solidFill>
+                <a:latin typeface="Arial"/>
+              </a:rPr>
+              <a:t>Praxiscase Dr. Mayer</a:t>
+            </a:r>
+          </a:p>
+        </p:txBody>
+      </p:sp>
+      <p:sp>
+        <p:nvSpPr>
+          <p:cNvPr id="6" name="TextBox 5"/>
+          <p:cNvSpPr txBox="1"/>
+          <p:nvPr/>
+        </p:nvSpPr>
+        <p:spPr>
+          <a:xfrm>
+            <a:off x="685800" y="4480560"/>
+            <a:ext cx="8653881" cy="1280160"/>
+          </a:xfrm>
+          <a:prstGeom prst="rect">
+            <a:avLst/>
+          </a:prstGeom>
+          <a:noFill/>
+        </p:spPr>
+        <p:txBody>
+          <a:bodyPr wrap="square">
+            <a:spAutoFit/>
+          </a:bodyPr>
+          <a:lstStyle/>
+          <a:p>
+            <a:pPr algn="l"/>
+            <a:r>
+              <a:rPr sz="1600" b="0" i="0">
+                <a:solidFill>
+                  <a:srgbClr val="C8D2E6"/>
+                </a:solidFill>
+                <a:latin typeface="Arial"/>
+              </a:rPr>
+              <a:t>Eine Zahnarztpraxis-Übernahme bewerten und finanzieren.</a:t>
+            </a:r>
+          </a:p>
+        </p:txBody>
+      </p:sp>
+      <p:sp>
+        <p:nvSpPr>
+          <p:cNvPr id="7" name="TextBox 6"/>
+          <p:cNvSpPr txBox="1"/>
+          <p:nvPr/>
+        </p:nvSpPr>
+        <p:spPr>
+          <a:xfrm>
+            <a:off x="685800" y="6355080"/>
+            <a:ext cx="10817352" cy="274320"/>
+          </a:xfrm>
+          <a:prstGeom prst="rect">
+            <a:avLst/>
+          </a:prstGeom>
+          <a:noFill/>
+        </p:spPr>
+        <p:txBody>
+          <a:bodyPr wrap="none">
+            <a:spAutoFit/>
+          </a:bodyPr>
+          <a:lstStyle/>
+          <a:p>
+            <a:pPr algn="l"/>
+            <a:r>
+              <a:rPr sz="700">
+                <a:solidFill>
+                  <a:srgbClr val="8CA0C3"/>
+                </a:solidFill>
+                <a:latin typeface="Consolas"/>
+              </a:rPr>
+              <a:t>FKB Campus  ·  M07</a:t>
+            </a:r>
+          </a:p>
+        </p:txBody>
+      </p:sp>
+    </p:spTree>
+  </p:cSld>
+  <p:clrMapOvr>
+    <a:masterClrMapping/>
+  </p:clrMapOvr>
+</p:sld>
+</file>
+
+<file path=ppt/slides/slide13.xml><?xml version="1.0" encoding="utf-8"?>
+<p:sld xmlns:a="http://schemas.openxmlformats.org/drawingml/2006/main" xmlns:p="http://schemas.openxmlformats.org/presentationml/2006/main" xmlns:r="http://schemas.openxmlformats.org/officeDocument/2006/relationships">
+  <p:cSld>
+    <p:spTree>
+      <p:nvGrpSpPr>
+        <p:cNvPr id="1" name=""/>
+        <p:cNvGrpSpPr/>
+        <p:nvPr/>
+      </p:nvGrpSpPr>
+      <p:grpSpPr/>
+      <p:sp>
+        <p:nvSpPr>
+          <p:cNvPr id="2" name="Rectangle 1"/>
+          <p:cNvSpPr/>
+          <p:nvPr/>
+        </p:nvSpPr>
+        <p:spPr>
+          <a:xfrm>
+            <a:off x="0" y="0"/>
+            <a:ext cx="12188952" cy="6858000"/>
+          </a:xfrm>
+          <a:prstGeom prst="rect">
+            <a:avLst/>
+          </a:prstGeom>
+          <a:solidFill>
+            <a:srgbClr val="FFFFFF"/>
+          </a:solidFill>
+          <a:ln>
+            <a:noFill/>
+          </a:ln>
+        </p:spPr>
+        <p:style>
+          <a:lnRef idx="1">
+            <a:schemeClr val="accent1"/>
+          </a:lnRef>
+          <a:fillRef idx="3">
+            <a:schemeClr val="accent1"/>
+          </a:fillRef>
+          <a:effectRef idx="2">
+            <a:schemeClr val="accent1"/>
+          </a:effectRef>
+          <a:fontRef idx="minor">
+            <a:schemeClr val="lt1"/>
+          </a:fontRef>
+        </p:style>
+        <p:txBody>
+          <a:bodyPr rtlCol="0" anchor="ctr"/>
+          <a:lstStyle/>
+          <a:p>
+            <a:pPr algn="ctr"/>
+          </a:p>
+        </p:txBody>
+      </p:sp>
+      <p:sp>
+        <p:nvSpPr>
+          <p:cNvPr id="3" name="Rectangle 2"/>
+          <p:cNvSpPr/>
+          <p:nvPr/>
+        </p:nvSpPr>
+        <p:spPr>
+          <a:xfrm>
+            <a:off x="0" y="0"/>
+            <a:ext cx="12188952" cy="50292"/>
+          </a:xfrm>
+          <a:prstGeom prst="rect">
+            <a:avLst/>
+          </a:prstGeom>
+          <a:solidFill>
+            <a:srgbClr val="1F2C56"/>
+          </a:solidFill>
+          <a:ln>
+            <a:noFill/>
+          </a:ln>
+        </p:spPr>
+        <p:style>
+          <a:lnRef idx="1">
+            <a:schemeClr val="accent1"/>
+          </a:lnRef>
+          <a:fillRef idx="3">
+            <a:schemeClr val="accent1"/>
+          </a:fillRef>
+          <a:effectRef idx="2">
+            <a:schemeClr val="accent1"/>
+          </a:effectRef>
+          <a:fontRef idx="minor">
+            <a:schemeClr val="lt1"/>
+          </a:fontRef>
+        </p:style>
+        <p:txBody>
+          <a:bodyPr rtlCol="0" anchor="ctr"/>
+          <a:lstStyle/>
+          <a:p>
+            <a:pPr algn="ctr"/>
+          </a:p>
+        </p:txBody>
+      </p:sp>
+      <p:sp>
+        <p:nvSpPr>
+          <p:cNvPr id="4" name="TextBox 3"/>
+          <p:cNvSpPr txBox="1"/>
+          <p:nvPr/>
+        </p:nvSpPr>
+        <p:spPr>
+          <a:xfrm>
+            <a:off x="685800" y="109728"/>
+            <a:ext cx="10817352" cy="228600"/>
+          </a:xfrm>
+          <a:prstGeom prst="rect">
+            <a:avLst/>
+          </a:prstGeom>
+          <a:noFill/>
+        </p:spPr>
+        <p:txBody>
+          <a:bodyPr wrap="none">
+            <a:spAutoFit/>
+          </a:bodyPr>
+          <a:lstStyle/>
+          <a:p>
+            <a:pPr algn="l"/>
+            <a:r>
+              <a:rPr sz="750">
+                <a:solidFill>
+                  <a:srgbClr val="78808C"/>
+                </a:solidFill>
+                <a:latin typeface="Consolas"/>
+              </a:rPr>
+              <a:t>M07  ·  ÜBERSICHT</a:t>
+            </a:r>
+          </a:p>
+        </p:txBody>
+      </p:sp>
+      <p:sp>
+        <p:nvSpPr>
+          <p:cNvPr id="5" name="TextBox 4"/>
+          <p:cNvSpPr txBox="1"/>
+          <p:nvPr/>
+        </p:nvSpPr>
+        <p:spPr>
+          <a:xfrm>
+            <a:off x="685800" y="502920"/>
+            <a:ext cx="10817352" cy="594360"/>
+          </a:xfrm>
+          <a:prstGeom prst="rect">
+            <a:avLst/>
+          </a:prstGeom>
+          <a:noFill/>
+        </p:spPr>
+        <p:txBody>
+          <a:bodyPr wrap="square">
+            <a:spAutoFit/>
+          </a:bodyPr>
+          <a:lstStyle/>
+          <a:p>
+            <a:pPr algn="l"/>
+            <a:r>
+              <a:rPr sz="2000" b="1" i="0">
+                <a:solidFill>
+                  <a:srgbClr val="1F2C56"/>
+                </a:solidFill>
+                <a:latin typeface="Arial"/>
+              </a:rPr>
+              <a:t>Praxisfall Dr. Mayer: Bewertung im Überblick</a:t>
             </a:r>
           </a:p>
         </p:txBody>
@@ -5447,10 +5892,9 @@
                 <a:tableStyleId>{5C22544A-7EE6-4342-B048-85BDC9FD1C3A}</a:tableStyleId>
               </a:tblPr>
               <a:tblGrid>
-                <a:gridCol w="2704338"/>
-                <a:gridCol w="2704338"/>
-                <a:gridCol w="2704338"/>
-                <a:gridCol w="2704338"/>
+                <a:gridCol w="3605784"/>
+                <a:gridCol w="3605784"/>
+                <a:gridCol w="3605784"/>
               </a:tblGrid>
               <a:tr h="384048">
                 <a:tc>
@@ -5465,7 +5909,7 @@
                           </a:solidFill>
                           <a:latin typeface="Arial"/>
                         </a:rPr>
-                        <a:t>Jahr</a:t>
+                        <a:t>Größe</a:t>
                       </a:r>
                     </a:p>
                   </a:txBody>
@@ -5487,7 +5931,7 @@
                           </a:solidFill>
                           <a:latin typeface="Arial"/>
                         </a:rPr>
-                        <a:t>Betriebseinnahmen</a:t>
+                        <a:t>Wert</a:t>
                       </a:r>
                     </a:p>
                   </a:txBody>
@@ -5509,29 +5953,7 @@
                           </a:solidFill>
                           <a:latin typeface="Arial"/>
                         </a:rPr>
-                        <a:t>Betriebsausgaben</a:t>
-                      </a:r>
-                    </a:p>
-                  </a:txBody>
-                  <a:tcPr>
-                    <a:solidFill>
-                      <a:srgbClr val="1F2C56"/>
-                    </a:solidFill>
-                  </a:tcPr>
-                </a:tc>
-                <a:tc>
-                  <a:txBody>
-                    <a:bodyPr/>
-                    <a:lstStyle/>
-                    <a:p>
-                      <a:r>
-                        <a:rPr sz="1100" b="1">
-                          <a:solidFill>
-                            <a:srgbClr val="FFFFFF"/>
-                          </a:solidFill>
-                          <a:latin typeface="Arial"/>
-                        </a:rPr>
-                        <a:t>Jahresüberschuss</a:t>
+                        <a:t>Bewertung</a:t>
                       </a:r>
                     </a:p>
                   </a:txBody>
@@ -5555,7 +5977,7 @@
                           </a:solidFill>
                           <a:latin typeface="Arial"/>
                         </a:rPr>
-                        <a:t>2023</a:t>
+                        <a:t>Goodwill (rechnerisch)</a:t>
                       </a:r>
                     </a:p>
                   </a:txBody>
@@ -5573,7 +5995,7 @@
                           </a:solidFill>
                           <a:latin typeface="Arial"/>
                         </a:rPr>
-                        <a:t>680.000 EUR</a:t>
+                        <a:t>390 TEUR</a:t>
                       </a:r>
                     </a:p>
                   </a:txBody>
@@ -5591,25 +6013,7 @@
                           </a:solidFill>
                           <a:latin typeface="Arial"/>
                         </a:rPr>
-                        <a:t>390.000 EUR</a:t>
-                      </a:r>
-                    </a:p>
-                  </a:txBody>
-                  <a:tcPr/>
-                </a:tc>
-                <a:tc>
-                  <a:txBody>
-                    <a:bodyPr/>
-                    <a:lstStyle/>
-                    <a:p>
-                      <a:r>
-                        <a:rPr sz="1050">
-                          <a:solidFill>
-                            <a:srgbClr val="3D5466"/>
-                          </a:solidFill>
-                          <a:latin typeface="Arial"/>
-                        </a:rPr>
-                        <a:t>290.000 EUR</a:t>
+                        <a:t>nach IDW S5</a:t>
                       </a:r>
                     </a:p>
                   </a:txBody>
@@ -5629,7 +6033,7 @@
                           </a:solidFill>
                           <a:latin typeface="Arial"/>
                         </a:rPr>
-                        <a:t>2024</a:t>
+                        <a:t>Vereinbarter Kaufpreis</a:t>
                       </a:r>
                     </a:p>
                   </a:txBody>
@@ -5647,7 +6051,7 @@
                           </a:solidFill>
                           <a:latin typeface="Arial"/>
                         </a:rPr>
-                        <a:t>710.000 EUR</a:t>
+                        <a:t>220 TEUR</a:t>
                       </a:r>
                     </a:p>
                   </a:txBody>
@@ -5665,25 +6069,7 @@
                           </a:solidFill>
                           <a:latin typeface="Arial"/>
                         </a:rPr>
-                        <a:t>400.000 EUR</a:t>
-                      </a:r>
-                    </a:p>
-                  </a:txBody>
-                  <a:tcPr/>
-                </a:tc>
-                <a:tc>
-                  <a:txBody>
-                    <a:bodyPr/>
-                    <a:lstStyle/>
-                    <a:p>
-                      <a:r>
-                        <a:rPr sz="1050">
-                          <a:solidFill>
-                            <a:srgbClr val="3D5466"/>
-                          </a:solidFill>
-                          <a:latin typeface="Arial"/>
-                        </a:rPr>
-                        <a:t>310.000 EUR</a:t>
+                        <a:t>günstig</a:t>
                       </a:r>
                     </a:p>
                   </a:txBody>
@@ -5703,7 +6089,7 @@
                           </a:solidFill>
                           <a:latin typeface="Arial"/>
                         </a:rPr>
-                        <a:t>2025</a:t>
+                        <a:t>DSCR (Ø)</a:t>
                       </a:r>
                     </a:p>
                   </a:txBody>
@@ -5721,7 +6107,7 @@
                           </a:solidFill>
                           <a:latin typeface="Arial"/>
                         </a:rPr>
-                        <a:t>700.000 EUR</a:t>
+                        <a:t>1,52</a:t>
                       </a:r>
                     </a:p>
                   </a:txBody>
@@ -5739,25 +6125,7 @@
                           </a:solidFill>
                           <a:latin typeface="Arial"/>
                         </a:rPr>
-                        <a:t>390.000 EUR</a:t>
-                      </a:r>
-                    </a:p>
-                  </a:txBody>
-                  <a:tcPr/>
-                </a:tc>
-                <a:tc>
-                  <a:txBody>
-                    <a:bodyPr/>
-                    <a:lstStyle/>
-                    <a:p>
-                      <a:r>
-                        <a:rPr sz="1050">
-                          <a:solidFill>
-                            <a:srgbClr val="3D5466"/>
-                          </a:solidFill>
-                          <a:latin typeface="Arial"/>
-                        </a:rPr>
-                        <a:t>310.000 EUR</a:t>
+                        <a:t>tragfähig</a:t>
                       </a:r>
                     </a:p>
                   </a:txBody>
@@ -5889,7 +6257,7 @@
 </p:sld>
 </file>
 
-<file path=ppt/slides/slide12.xml><?xml version="1.0" encoding="utf-8"?>
+<file path=ppt/slides/slide14.xml><?xml version="1.0" encoding="utf-8"?>
 <p:sld xmlns:a="http://schemas.openxmlformats.org/drawingml/2006/main" xmlns:p="http://schemas.openxmlformats.org/presentationml/2006/main" xmlns:r="http://schemas.openxmlformats.org/officeDocument/2006/relationships">
   <p:cSld>
     <p:spTree>
@@ -6015,7 +6383,7 @@
                 </a:solidFill>
                 <a:latin typeface="Consolas"/>
               </a:rPr>
-              <a:t>M07  ·  INHALT</a:t>
+              <a:t>M07  ·  ARBEITSBLATT</a:t>
             </a:r>
           </a:p>
         </p:txBody>
@@ -6136,7 +6504,7 @@
                 </a:solidFill>
                 <a:latin typeface="Arial"/>
               </a:rPr>
-              <a:t>AB-2: Checkliste Heilberufe-Erstgespräch (15 Punkte)</a:t>
+              <a:t>Praxisübernahme Dr. Mayer bearbeiten</a:t>
             </a:r>
           </a:p>
         </p:txBody>
@@ -6149,8 +6517,8 @@
         </p:nvSpPr>
         <p:spPr>
           <a:xfrm>
-            <a:off x="685800" y="1417320"/>
-            <a:ext cx="10817352" cy="4892040"/>
+            <a:off x="685800" y="1554480"/>
+            <a:ext cx="10817352" cy="3840480"/>
           </a:xfrm>
           <a:prstGeom prst="rect">
             <a:avLst/>
@@ -6172,13 +6540,13 @@
               </a:spcAft>
             </a:pPr>
             <a:r>
-              <a:rPr sz="1300">
+              <a:rPr sz="1400">
                 <a:solidFill>
                   <a:srgbClr val="3D5466"/>
                 </a:solidFill>
                 <a:latin typeface="Arial"/>
               </a:rPr>
-              <a:t>▸  Nutzen Sie diese Checkliste zur Vorbereitung und Strukturierung von Erstgesprächen mit Heilberufe-Kunden.</a:t>
+              <a:t>▸  Bewerten Sie die Zahnarztpraxis mit dem IDW-S5-Modell (XLSX-Praxisbewertung).</a:t>
             </a:r>
           </a:p>
           <a:p>
@@ -6191,13 +6559,13 @@
               </a:spcAft>
             </a:pPr>
             <a:r>
-              <a:rPr sz="1300">
+              <a:rPr sz="1400">
                 <a:solidFill>
                   <a:srgbClr val="3D5466"/>
                 </a:solidFill>
                 <a:latin typeface="Arial"/>
               </a:rPr>
-              <a:t>▸  Branche &amp; Zulassung</a:t>
+              <a:t>▸  Beurteilen Sie den Kaufpreis und die Finanzierungsstruktur (DSCR).</a:t>
             </a:r>
           </a:p>
           <a:p>
@@ -6210,191 +6578,98 @@
               </a:spcAft>
             </a:pPr>
             <a:r>
-              <a:rPr sz="1300">
+              <a:rPr sz="1400">
                 <a:solidFill>
                   <a:srgbClr val="3D5466"/>
                 </a:solidFill>
                 <a:latin typeface="Arial"/>
               </a:rPr>
-              <a:t>▸  [ ] 1. Zulassungsart: GKV-Zulassung, Privatarzt, MVZ-Anstellung?</a:t>
-            </a:r>
-          </a:p>
-          <a:p>
-            <a:pPr marL="190500" indent="-190500">
-              <a:spcBef>
-                <a:spcPts val="400"/>
-              </a:spcBef>
-              <a:spcAft>
-                <a:spcPts val="200"/>
-              </a:spcAft>
-            </a:pPr>
-            <a:r>
-              <a:rPr sz="1300">
-                <a:solidFill>
-                  <a:srgbClr val="3D5466"/>
+              <a:t>▸  Nutzen Sie die Checkliste Heilberufe-Erstgespräch (AB-2).</a:t>
+            </a:r>
+          </a:p>
+        </p:txBody>
+      </p:sp>
+      <p:sp>
+        <p:nvSpPr>
+          <p:cNvPr id="9" name="Rectangle 8"/>
+          <p:cNvSpPr/>
+          <p:nvPr/>
+        </p:nvSpPr>
+        <p:spPr>
+          <a:xfrm>
+            <a:off x="685800" y="5486400"/>
+            <a:ext cx="10817352" cy="640080"/>
+          </a:xfrm>
+          <a:prstGeom prst="rect">
+            <a:avLst/>
+          </a:prstGeom>
+          <a:solidFill>
+            <a:srgbClr val="1F2C56"/>
+          </a:solidFill>
+          <a:ln>
+            <a:noFill/>
+          </a:ln>
+        </p:spPr>
+        <p:style>
+          <a:lnRef idx="1">
+            <a:schemeClr val="accent1"/>
+          </a:lnRef>
+          <a:fillRef idx="3">
+            <a:schemeClr val="accent1"/>
+          </a:fillRef>
+          <a:effectRef idx="2">
+            <a:schemeClr val="accent1"/>
+          </a:effectRef>
+          <a:fontRef idx="minor">
+            <a:schemeClr val="lt1"/>
+          </a:fontRef>
+        </p:style>
+        <p:txBody>
+          <a:bodyPr rtlCol="0" anchor="ctr"/>
+          <a:lstStyle/>
+          <a:p>
+            <a:pPr algn="ctr"/>
+          </a:p>
+        </p:txBody>
+      </p:sp>
+      <p:sp>
+        <p:nvSpPr>
+          <p:cNvPr id="10" name="TextBox 9"/>
+          <p:cNvSpPr txBox="1"/>
+          <p:nvPr/>
+        </p:nvSpPr>
+        <p:spPr>
+          <a:xfrm>
+            <a:off x="868680" y="5596128"/>
+            <a:ext cx="10451592" cy="457200"/>
+          </a:xfrm>
+          <a:prstGeom prst="rect">
+            <a:avLst/>
+          </a:prstGeom>
+          <a:noFill/>
+        </p:spPr>
+        <p:txBody>
+          <a:bodyPr wrap="square">
+            <a:spAutoFit/>
+          </a:bodyPr>
+          <a:lstStyle/>
+          <a:p>
+            <a:pPr algn="l"/>
+            <a:r>
+              <a:rPr sz="1300" b="1" i="0">
+                <a:solidFill>
+                  <a:srgbClr val="FFFFFF"/>
                 </a:solidFill>
                 <a:latin typeface="Arial"/>
               </a:rPr>
-              <a:t>▸  [ ] 2. KV-Bezirk und Versorgungsgebiet – überversorgt oder Mangelgebiet?</a:t>
-            </a:r>
-          </a:p>
-          <a:p>
-            <a:pPr marL="190500" indent="-190500">
-              <a:spcBef>
-                <a:spcPts val="400"/>
-              </a:spcBef>
-              <a:spcAft>
-                <a:spcPts val="200"/>
-              </a:spcAft>
-            </a:pPr>
-            <a:r>
-              <a:rPr sz="1300">
-                <a:solidFill>
-                  <a:srgbClr val="3D5466"/>
-                </a:solidFill>
-                <a:latin typeface="Arial"/>
-              </a:rPr>
-              <a:t>▸  [ ] 3. Berufsbezeichnung und Kammerzugehörigkeit klären</a:t>
-            </a:r>
-          </a:p>
-          <a:p>
-            <a:pPr marL="190500" indent="-190500">
-              <a:spcBef>
-                <a:spcPts val="400"/>
-              </a:spcBef>
-              <a:spcAft>
-                <a:spcPts val="200"/>
-              </a:spcAft>
-            </a:pPr>
-            <a:r>
-              <a:rPr sz="1300">
-                <a:solidFill>
-                  <a:srgbClr val="3D5466"/>
-                </a:solidFill>
-                <a:latin typeface="Arial"/>
-              </a:rPr>
-              <a:t>▸  [ ] 4. Einzelpraxis oder BAG/Gemeinschaftspraxis? → Bei Berufsausübungsgemeinschaft (BAG): Gesellschaftsvertrag anfordern; Sicherheitenkonzept und Bonitätsprüfung gelten für alle Partner</a:t>
-            </a:r>
-          </a:p>
-          <a:p>
-            <a:pPr marL="190500" indent="-190500">
-              <a:spcBef>
-                <a:spcPts val="400"/>
-              </a:spcBef>
-              <a:spcAft>
-                <a:spcPts val="200"/>
-              </a:spcAft>
-            </a:pPr>
-            <a:r>
-              <a:rPr sz="1300">
-                <a:solidFill>
-                  <a:srgbClr val="3D5466"/>
-                </a:solidFill>
-                <a:latin typeface="Arial"/>
-              </a:rPr>
-              <a:t>▸  [ ] 5. Umsatzsteuer-Status klären (§ 4 Nr. 14 UStG: Heilbehandlungen grds. USt-frei; Ausnahmen: Gutachtertätigkeit, Schönheitschirurgie ohne Heilzweck → partielle USt-Pflicht möglich)</a:t>
-            </a:r>
-          </a:p>
-          <a:p>
-            <a:pPr marL="190500" indent="-190500">
-              <a:spcBef>
-                <a:spcPts val="400"/>
-              </a:spcBef>
-              <a:spcAft>
-                <a:spcPts val="200"/>
-              </a:spcAft>
-            </a:pPr>
-            <a:r>
-              <a:rPr sz="1300">
-                <a:solidFill>
-                  <a:srgbClr val="3D5466"/>
-                </a:solidFill>
-                <a:latin typeface="Arial"/>
-              </a:rPr>
-              <a:t>▸  Einkommenssituation</a:t>
-            </a:r>
-          </a:p>
-          <a:p>
-            <a:pPr marL="190500" indent="-190500">
-              <a:spcBef>
-                <a:spcPts val="400"/>
-              </a:spcBef>
-              <a:spcAft>
-                <a:spcPts val="200"/>
-              </a:spcAft>
-            </a:pPr>
-            <a:r>
-              <a:rPr sz="1300">
-                <a:solidFill>
-                  <a:srgbClr val="3D5466"/>
-                </a:solidFill>
-                <a:latin typeface="Arial"/>
-              </a:rPr>
-              <a:t>▸  [ ] 6. Einnahmenquellen: GKV-Anteil / PKV-Anteil / Selbstzahler</a:t>
-            </a:r>
-          </a:p>
-          <a:p>
-            <a:pPr marL="190500" indent="-190500">
-              <a:spcBef>
-                <a:spcPts val="400"/>
-              </a:spcBef>
-              <a:spcAft>
-                <a:spcPts val="200"/>
-              </a:spcAft>
-            </a:pPr>
-            <a:r>
-              <a:rPr sz="1300">
-                <a:solidFill>
-                  <a:srgbClr val="3D5466"/>
-                </a:solidFill>
-                <a:latin typeface="Arial"/>
-              </a:rPr>
-              <a:t>▸  [ ] 7. EÜR letzter 3 Jahre + Steuerbescheide anfordern</a:t>
-            </a:r>
-          </a:p>
-          <a:p>
-            <a:pPr marL="190500" indent="-190500">
-              <a:spcBef>
-                <a:spcPts val="400"/>
-              </a:spcBef>
-              <a:spcAft>
-                <a:spcPts val="200"/>
-              </a:spcAft>
-            </a:pPr>
-            <a:r>
-              <a:rPr sz="1300">
-                <a:solidFill>
-                  <a:srgbClr val="3D5466"/>
-                </a:solidFill>
-                <a:latin typeface="Arial"/>
-              </a:rPr>
-              <a:t>▸  [ ] 8. Rückstände oder laufende Regressverfahren erfragen</a:t>
-            </a:r>
-          </a:p>
-          <a:p>
-            <a:pPr marL="190500" indent="-190500">
-              <a:spcBef>
-                <a:spcPts val="400"/>
-              </a:spcBef>
-              <a:spcAft>
-                <a:spcPts val="200"/>
-              </a:spcAft>
-            </a:pPr>
-            <a:r>
-              <a:rPr sz="1300">
-                <a:solidFill>
-                  <a:srgbClr val="3D5466"/>
-                </a:solidFill>
-                <a:latin typeface="Arial"/>
-              </a:rPr>
-              <a:t>▸  [ ] 9. Betriebsausgaben auf Plausibilität prüfen (Personalquote, Mietquote)</a:t>
-            </a:r>
-          </a:p>
-        </p:txBody>
-      </p:sp>
-      <p:sp>
-        <p:nvSpPr>
-          <p:cNvPr id="9" name="Rectangle 8"/>
+              <a:t>→  Bearbeitung im Teilnehmer-Workbook (Arbeitsblatt mit Ausfüllfeldern)</a:t>
+            </a:r>
+          </a:p>
+        </p:txBody>
+      </p:sp>
+      <p:sp>
+        <p:nvSpPr>
+          <p:cNvPr id="11" name="Rectangle 10"/>
           <p:cNvSpPr/>
           <p:nvPr/>
         </p:nvSpPr>
@@ -6437,7 +6712,7 @@
       </p:sp>
       <p:sp>
         <p:nvSpPr>
-          <p:cNvPr id="10" name="TextBox 9"/>
+          <p:cNvPr id="12" name="TextBox 11"/>
           <p:cNvSpPr txBox="1"/>
           <p:nvPr/>
         </p:nvSpPr>
@@ -6478,7 +6753,7 @@
 </p:sld>
 </file>
 
-<file path=ppt/slides/slide13.xml><?xml version="1.0" encoding="utf-8"?>
+<file path=ppt/slides/slide15.xml><?xml version="1.0" encoding="utf-8"?>
 <p:sld xmlns:a="http://schemas.openxmlformats.org/drawingml/2006/main" xmlns:p="http://schemas.openxmlformats.org/presentationml/2006/main" xmlns:r="http://schemas.openxmlformats.org/officeDocument/2006/relationships">
   <p:cSld>
     <p:spTree>
@@ -6725,7 +7000,7 @@
                 </a:solidFill>
                 <a:latin typeface="Arial"/>
               </a:rPr>
-              <a:t>Reflexionsfragen</a:t>
+              <a:t>Prinzip dieses Moduls</a:t>
             </a:r>
           </a:p>
         </p:txBody>
@@ -6751,6 +7026,25 @@
             <a:spAutoFit/>
           </a:bodyPr>
           <a:lstStyle/>
+          <a:p>
+            <a:pPr marL="177800" indent="-177800">
+              <a:spcBef>
+                <a:spcPts val="600"/>
+              </a:spcBef>
+              <a:spcAft>
+                <a:spcPts val="200"/>
+              </a:spcAft>
+            </a:pPr>
+            <a:r>
+              <a:rPr sz="1200" i="1">
+                <a:solidFill>
+                  <a:srgbClr val="3D5466"/>
+                </a:solidFill>
+                <a:latin typeface="Arial"/>
+              </a:rPr>
+              <a:t>→  Kenne die Spielregeln der Branche, bevor du über Finanzierung sprichst.</a:t>
+            </a:r>
+          </a:p>
           <a:p>
             <a:pPr marL="190500" indent="-190500">
               <a:spcBef>
@@ -6767,9 +7061,370 @@
                 </a:solidFill>
                 <a:latin typeface="Arial"/>
               </a:rPr>
-              <a:t>▸  Welche drei Informationen fehlen Ihnen typischerweise beim ersten Gespräch mit einem Heilberufe-Kunden, und wie würden Sie diese strukturiert erfragen?</a:t>
-            </a:r>
-          </a:p>
+              <a:t>▸  Freier Beruf ≠ Gewerbe, EÜR ≠ Bilanz, Praxiswert ≠ Substanzwert – branchenfremde Maßstäbe führen in die Irre.</a:t>
+            </a:r>
+          </a:p>
+        </p:txBody>
+      </p:sp>
+      <p:sp>
+        <p:nvSpPr>
+          <p:cNvPr id="9" name="Rectangle 8"/>
+          <p:cNvSpPr/>
+          <p:nvPr/>
+        </p:nvSpPr>
+        <p:spPr>
+          <a:xfrm>
+            <a:off x="0" y="6510528"/>
+            <a:ext cx="12188952" cy="347472"/>
+          </a:xfrm>
+          <a:prstGeom prst="rect">
+            <a:avLst/>
+          </a:prstGeom>
+          <a:solidFill>
+            <a:srgbClr val="0A1937"/>
+          </a:solidFill>
+          <a:ln>
+            <a:noFill/>
+          </a:ln>
+        </p:spPr>
+        <p:style>
+          <a:lnRef idx="1">
+            <a:schemeClr val="accent1"/>
+          </a:lnRef>
+          <a:fillRef idx="3">
+            <a:schemeClr val="accent1"/>
+          </a:fillRef>
+          <a:effectRef idx="2">
+            <a:schemeClr val="accent1"/>
+          </a:effectRef>
+          <a:fontRef idx="minor">
+            <a:schemeClr val="lt1"/>
+          </a:fontRef>
+        </p:style>
+        <p:txBody>
+          <a:bodyPr rtlCol="0" anchor="ctr"/>
+          <a:lstStyle/>
+          <a:p>
+            <a:pPr algn="ctr"/>
+          </a:p>
+        </p:txBody>
+      </p:sp>
+      <p:sp>
+        <p:nvSpPr>
+          <p:cNvPr id="10" name="TextBox 9"/>
+          <p:cNvSpPr txBox="1"/>
+          <p:nvPr/>
+        </p:nvSpPr>
+        <p:spPr>
+          <a:xfrm>
+            <a:off x="685800" y="6583680"/>
+            <a:ext cx="6490411" cy="256032"/>
+          </a:xfrm>
+          <a:prstGeom prst="rect">
+            <a:avLst/>
+          </a:prstGeom>
+          <a:noFill/>
+        </p:spPr>
+        <p:txBody>
+          <a:bodyPr wrap="none">
+            <a:spAutoFit/>
+          </a:bodyPr>
+          <a:lstStyle/>
+          <a:p>
+            <a:pPr algn="l"/>
+            <a:r>
+              <a:rPr sz="700">
+                <a:solidFill>
+                  <a:srgbClr val="A0B4D2"/>
+                </a:solidFill>
+                <a:latin typeface="Consolas"/>
+              </a:rPr>
+              <a:t>FKB Campus  ·  M07</a:t>
+            </a:r>
+          </a:p>
+        </p:txBody>
+      </p:sp>
+    </p:spTree>
+  </p:cSld>
+  <p:clrMapOvr>
+    <a:masterClrMapping/>
+  </p:clrMapOvr>
+</p:sld>
+</file>
+
+<file path=ppt/slides/slide16.xml><?xml version="1.0" encoding="utf-8"?>
+<p:sld xmlns:a="http://schemas.openxmlformats.org/drawingml/2006/main" xmlns:p="http://schemas.openxmlformats.org/presentationml/2006/main" xmlns:r="http://schemas.openxmlformats.org/officeDocument/2006/relationships">
+  <p:cSld>
+    <p:spTree>
+      <p:nvGrpSpPr>
+        <p:cNvPr id="1" name=""/>
+        <p:cNvGrpSpPr/>
+        <p:nvPr/>
+      </p:nvGrpSpPr>
+      <p:grpSpPr/>
+      <p:sp>
+        <p:nvSpPr>
+          <p:cNvPr id="2" name="Rectangle 1"/>
+          <p:cNvSpPr/>
+          <p:nvPr/>
+        </p:nvSpPr>
+        <p:spPr>
+          <a:xfrm>
+            <a:off x="0" y="0"/>
+            <a:ext cx="12188952" cy="6858000"/>
+          </a:xfrm>
+          <a:prstGeom prst="rect">
+            <a:avLst/>
+          </a:prstGeom>
+          <a:solidFill>
+            <a:srgbClr val="EDEDF3"/>
+          </a:solidFill>
+          <a:ln>
+            <a:noFill/>
+          </a:ln>
+        </p:spPr>
+        <p:style>
+          <a:lnRef idx="1">
+            <a:schemeClr val="accent1"/>
+          </a:lnRef>
+          <a:fillRef idx="3">
+            <a:schemeClr val="accent1"/>
+          </a:fillRef>
+          <a:effectRef idx="2">
+            <a:schemeClr val="accent1"/>
+          </a:effectRef>
+          <a:fontRef idx="minor">
+            <a:schemeClr val="lt1"/>
+          </a:fontRef>
+        </p:style>
+        <p:txBody>
+          <a:bodyPr rtlCol="0" anchor="ctr"/>
+          <a:lstStyle/>
+          <a:p>
+            <a:pPr algn="ctr"/>
+          </a:p>
+        </p:txBody>
+      </p:sp>
+      <p:sp>
+        <p:nvSpPr>
+          <p:cNvPr id="3" name="Rectangle 2"/>
+          <p:cNvSpPr/>
+          <p:nvPr/>
+        </p:nvSpPr>
+        <p:spPr>
+          <a:xfrm>
+            <a:off x="0" y="0"/>
+            <a:ext cx="12188952" cy="50292"/>
+          </a:xfrm>
+          <a:prstGeom prst="rect">
+            <a:avLst/>
+          </a:prstGeom>
+          <a:solidFill>
+            <a:srgbClr val="1F2C56"/>
+          </a:solidFill>
+          <a:ln>
+            <a:noFill/>
+          </a:ln>
+        </p:spPr>
+        <p:style>
+          <a:lnRef idx="1">
+            <a:schemeClr val="accent1"/>
+          </a:lnRef>
+          <a:fillRef idx="3">
+            <a:schemeClr val="accent1"/>
+          </a:fillRef>
+          <a:effectRef idx="2">
+            <a:schemeClr val="accent1"/>
+          </a:effectRef>
+          <a:fontRef idx="minor">
+            <a:schemeClr val="lt1"/>
+          </a:fontRef>
+        </p:style>
+        <p:txBody>
+          <a:bodyPr rtlCol="0" anchor="ctr"/>
+          <a:lstStyle/>
+          <a:p>
+            <a:pPr algn="ctr"/>
+          </a:p>
+        </p:txBody>
+      </p:sp>
+      <p:sp>
+        <p:nvSpPr>
+          <p:cNvPr id="4" name="TextBox 3"/>
+          <p:cNvSpPr txBox="1"/>
+          <p:nvPr/>
+        </p:nvSpPr>
+        <p:spPr>
+          <a:xfrm>
+            <a:off x="685800" y="109728"/>
+            <a:ext cx="10817352" cy="228600"/>
+          </a:xfrm>
+          <a:prstGeom prst="rect">
+            <a:avLst/>
+          </a:prstGeom>
+          <a:noFill/>
+        </p:spPr>
+        <p:txBody>
+          <a:bodyPr wrap="none">
+            <a:spAutoFit/>
+          </a:bodyPr>
+          <a:lstStyle/>
+          <a:p>
+            <a:pPr algn="l"/>
+            <a:r>
+              <a:rPr sz="750">
+                <a:solidFill>
+                  <a:srgbClr val="78808C"/>
+                </a:solidFill>
+                <a:latin typeface="Consolas"/>
+              </a:rPr>
+              <a:t>M07  ·  INHALT</a:t>
+            </a:r>
+          </a:p>
+        </p:txBody>
+      </p:sp>
+      <p:sp>
+        <p:nvSpPr>
+          <p:cNvPr id="5" name="Rectangle 4"/>
+          <p:cNvSpPr/>
+          <p:nvPr/>
+        </p:nvSpPr>
+        <p:spPr>
+          <a:xfrm>
+            <a:off x="0" y="1234440"/>
+            <a:ext cx="12188952" cy="12700"/>
+          </a:xfrm>
+          <a:prstGeom prst="rect">
+            <a:avLst/>
+          </a:prstGeom>
+          <a:solidFill>
+            <a:srgbClr val="D8DFE4"/>
+          </a:solidFill>
+          <a:ln>
+            <a:noFill/>
+          </a:ln>
+        </p:spPr>
+        <p:style>
+          <a:lnRef idx="1">
+            <a:schemeClr val="accent1"/>
+          </a:lnRef>
+          <a:fillRef idx="3">
+            <a:schemeClr val="accent1"/>
+          </a:fillRef>
+          <a:effectRef idx="2">
+            <a:schemeClr val="accent1"/>
+          </a:effectRef>
+          <a:fontRef idx="minor">
+            <a:schemeClr val="lt1"/>
+          </a:fontRef>
+        </p:style>
+        <p:txBody>
+          <a:bodyPr rtlCol="0" anchor="ctr"/>
+          <a:lstStyle/>
+          <a:p>
+            <a:pPr algn="ctr"/>
+          </a:p>
+        </p:txBody>
+      </p:sp>
+      <p:sp>
+        <p:nvSpPr>
+          <p:cNvPr id="6" name="Rectangle 5"/>
+          <p:cNvSpPr/>
+          <p:nvPr/>
+        </p:nvSpPr>
+        <p:spPr>
+          <a:xfrm>
+            <a:off x="685800" y="502920"/>
+            <a:ext cx="36576" cy="658368"/>
+          </a:xfrm>
+          <a:prstGeom prst="rect">
+            <a:avLst/>
+          </a:prstGeom>
+          <a:solidFill>
+            <a:srgbClr val="D9C089"/>
+          </a:solidFill>
+          <a:ln>
+            <a:noFill/>
+          </a:ln>
+        </p:spPr>
+        <p:style>
+          <a:lnRef idx="1">
+            <a:schemeClr val="accent1"/>
+          </a:lnRef>
+          <a:fillRef idx="3">
+            <a:schemeClr val="accent1"/>
+          </a:fillRef>
+          <a:effectRef idx="2">
+            <a:schemeClr val="accent1"/>
+          </a:effectRef>
+          <a:fontRef idx="minor">
+            <a:schemeClr val="lt1"/>
+          </a:fontRef>
+        </p:style>
+        <p:txBody>
+          <a:bodyPr rtlCol="0" anchor="ctr"/>
+          <a:lstStyle/>
+          <a:p>
+            <a:pPr algn="ctr"/>
+          </a:p>
+        </p:txBody>
+      </p:sp>
+      <p:sp>
+        <p:nvSpPr>
+          <p:cNvPr id="7" name="TextBox 6"/>
+          <p:cNvSpPr txBox="1"/>
+          <p:nvPr/>
+        </p:nvSpPr>
+        <p:spPr>
+          <a:xfrm>
+            <a:off x="813816" y="502920"/>
+            <a:ext cx="10634472" cy="685800"/>
+          </a:xfrm>
+          <a:prstGeom prst="rect">
+            <a:avLst/>
+          </a:prstGeom>
+          <a:noFill/>
+        </p:spPr>
+        <p:txBody>
+          <a:bodyPr wrap="square">
+            <a:spAutoFit/>
+          </a:bodyPr>
+          <a:lstStyle/>
+          <a:p>
+            <a:pPr algn="l"/>
+            <a:r>
+              <a:rPr sz="2400" b="1" i="0">
+                <a:solidFill>
+                  <a:srgbClr val="1F2C56"/>
+                </a:solidFill>
+                <a:latin typeface="Arial"/>
+              </a:rPr>
+              <a:t>Reflexion und Selbstcheck</a:t>
+            </a:r>
+          </a:p>
+        </p:txBody>
+      </p:sp>
+      <p:sp>
+        <p:nvSpPr>
+          <p:cNvPr id="8" name="TextBox 7"/>
+          <p:cNvSpPr txBox="1"/>
+          <p:nvPr/>
+        </p:nvSpPr>
+        <p:spPr>
+          <a:xfrm>
+            <a:off x="685800" y="1417320"/>
+            <a:ext cx="10817352" cy="4892040"/>
+          </a:xfrm>
+          <a:prstGeom prst="rect">
+            <a:avLst/>
+          </a:prstGeom>
+          <a:noFill/>
+        </p:spPr>
+        <p:txBody>
+          <a:bodyPr wrap="square" anchor="ctr">
+            <a:spAutoFit/>
+          </a:bodyPr>
+          <a:lstStyle/>
           <a:p>
             <a:pPr marL="190500" indent="-190500">
               <a:spcBef>
@@ -6786,7 +7441,7 @@
                 </a:solidFill>
                 <a:latin typeface="Arial"/>
               </a:rPr>
-              <a:t>▸  Ein Arzt zeigt eine EÜR mit 500.000 EUR Betriebseinnahmen und 350.000 EUR Betriebsausgaben. Was müssen Sie zusätzlich zum Jahresüberschuss wissen, um eine fundierte Kreditentscheidung treffen zu können?</a:t>
+              <a:t>▸  Welchen Heilberufe-Kunden haben Sie bisher mit gewerblichen Maßstäben bewertet?</a:t>
             </a:r>
           </a:p>
           <a:p>
@@ -6805,7 +7460,26 @@
                 </a:solidFill>
                 <a:latin typeface="Arial"/>
               </a:rPr>
-              <a:t>▸  Wo liegt der wesentliche Unterschied zwischen der Finanzierung einer Zahnarztpraxis und der Finanzierung eines KMU-Betriebs? Was bedeutet das für Ihre Sicherheitenstrategie?</a:t>
+              <a:t>▸  Woran erkennen Sie im Erstgespräch, ob ein Praxiswert realistisch angesetzt ist?</a:t>
+            </a:r>
+          </a:p>
+          <a:p>
+            <a:pPr marL="190500" indent="-190500">
+              <a:spcBef>
+                <a:spcPts val="400"/>
+              </a:spcBef>
+              <a:spcAft>
+                <a:spcPts val="200"/>
+              </a:spcAft>
+            </a:pPr>
+            <a:r>
+              <a:rPr sz="1300">
+                <a:solidFill>
+                  <a:srgbClr val="3D5466"/>
+                </a:solidFill>
+                <a:latin typeface="Arial"/>
+              </a:rPr>
+              <a:t>▸  Welche Absicherung sprechen Sie bei einer Praxisübernahme als Erstes an?</a:t>
             </a:r>
           </a:p>
         </p:txBody>
@@ -8647,7 +9321,7 @@
                 </a:solidFill>
                 <a:latin typeface="Arial"/>
               </a:rPr>
-              <a:t>Theorie-Input 1: Freie Berufe – rechtliche und wirtschaftliche Grundlagen</a:t>
+              <a:t>Kenne die Spielregeln der Branche</a:t>
             </a:r>
           </a:p>
         </p:txBody>
@@ -8669,27 +9343,27 @@
           <a:noFill/>
         </p:spPr>
         <p:txBody>
-          <a:bodyPr wrap="square">
+          <a:bodyPr wrap="square" anchor="ctr">
             <a:spAutoFit/>
           </a:bodyPr>
           <a:lstStyle/>
           <a:p>
-            <a:pPr>
+            <a:pPr marL="177800" indent="-177800">
               <a:spcBef>
-                <a:spcPts val="1000"/>
+                <a:spcPts val="600"/>
               </a:spcBef>
               <a:spcAft>
                 <a:spcPts val="200"/>
               </a:spcAft>
             </a:pPr>
             <a:r>
-              <a:rPr sz="800" b="1">
-                <a:solidFill>
-                  <a:srgbClr val="78808C"/>
-                </a:solidFill>
-                <a:latin typeface="Consolas"/>
-              </a:rPr>
-              <a:t>ABGRENZUNG: FREIER BERUF VS. GEWERBE</a:t>
+              <a:rPr sz="1200" i="1">
+                <a:solidFill>
+                  <a:srgbClr val="3D5466"/>
+                </a:solidFill>
+                <a:latin typeface="Arial"/>
+              </a:rPr>
+              <a:t>→  Kenne die Spielregeln der Branche, bevor du über Finanzierung sprichst.</a:t>
             </a:r>
           </a:p>
           <a:p>
@@ -8708,7 +9382,7 @@
                 </a:solidFill>
                 <a:latin typeface="Arial"/>
               </a:rPr>
-              <a:t>▸  Die praktischen Konsequenzen für die Bankbeziehung:</a:t>
+              <a:t>▸  Freier Beruf ist nicht Gewerbe, EÜR ist nicht Bilanz, Praxiswert ist nicht Substanzwert.</a:t>
             </a:r>
           </a:p>
           <a:p>
@@ -8727,178 +9401,7 @@
                 </a:solidFill>
                 <a:latin typeface="Arial"/>
               </a:rPr>
-              <a:t>▸  Quellen: § 18 EStG; § 4 Abs. 3 EStG; Gumpert &amp; Kausch (2022 )</a:t>
-            </a:r>
-          </a:p>
-          <a:p>
-            <a:pPr>
-              <a:spcBef>
-                <a:spcPts val="1000"/>
-              </a:spcBef>
-              <a:spcAft>
-                <a:spcPts val="200"/>
-              </a:spcAft>
-            </a:pPr>
-            <a:r>
-              <a:rPr sz="800" b="1">
-                <a:solidFill>
-                  <a:srgbClr val="78808C"/>
-                </a:solidFill>
-                <a:latin typeface="Consolas"/>
-              </a:rPr>
-              <a:t>PRAXISRELEVANZ: EINZELPRAXIS, BERUFSAUSÜBUNGSGEMEINSCHAFT (BAG) UND MVZ IM VERGLEICH</a:t>
-            </a:r>
-          </a:p>
-          <a:p>
-            <a:pPr marL="190500" indent="-190500">
-              <a:spcBef>
-                <a:spcPts val="400"/>
-              </a:spcBef>
-              <a:spcAft>
-                <a:spcPts val="200"/>
-              </a:spcAft>
-            </a:pPr>
-            <a:r>
-              <a:rPr sz="1300">
-                <a:solidFill>
-                  <a:srgbClr val="3D5466"/>
-                </a:solidFill>
-                <a:latin typeface="Arial"/>
-              </a:rPr>
-              <a:t>▸  Die bloße Abgrenzung „Freier Beruf vs. Gewerbe" greift in der Beratungspraxis zu kurz. Entscheidend für die Kreditanalyse ist auch die Organisationsform, in der der Heilberuf ausgeübt wird:</a:t>
-            </a:r>
-          </a:p>
-          <a:p>
-            <a:pPr marL="190500" indent="-190500">
-              <a:spcBef>
-                <a:spcPts val="400"/>
-              </a:spcBef>
-              <a:spcAft>
-                <a:spcPts val="200"/>
-              </a:spcAft>
-            </a:pPr>
-            <a:r>
-              <a:rPr sz="1300">
-                <a:solidFill>
-                  <a:srgbClr val="3D5466"/>
-                </a:solidFill>
-                <a:latin typeface="Arial"/>
-              </a:rPr>
-              <a:t>▸  Für den Berater – Daumenregel:</a:t>
-            </a:r>
-          </a:p>
-          <a:p>
-            <a:pPr marL="190500" indent="-190500">
-              <a:spcBef>
-                <a:spcPts val="400"/>
-              </a:spcBef>
-              <a:spcAft>
-                <a:spcPts val="200"/>
-              </a:spcAft>
-            </a:pPr>
-            <a:r>
-              <a:rPr sz="1300">
-                <a:solidFill>
-                  <a:srgbClr val="3D5466"/>
-                </a:solidFill>
-                <a:latin typeface="Arial"/>
-              </a:rPr>
-              <a:t>▸  Einzelpraxis: Standardvorgehen gemäß M07</a:t>
-            </a:r>
-          </a:p>
-          <a:p>
-            <a:pPr marL="190500" indent="-190500">
-              <a:spcBef>
-                <a:spcPts val="400"/>
-              </a:spcBef>
-              <a:spcAft>
-                <a:spcPts val="200"/>
-              </a:spcAft>
-            </a:pPr>
-            <a:r>
-              <a:rPr sz="1300">
-                <a:solidFill>
-                  <a:srgbClr val="3D5466"/>
-                </a:solidFill>
-                <a:latin typeface="Arial"/>
-              </a:rPr>
-              <a:t>▸  BAG mit 2–3 Partnern: immer Gesellschaftsvertrag anfordern, Bonitätsprüfung aller Partner, Regelung bei Ausscheiden eines Partners klären</a:t>
-            </a:r>
-          </a:p>
-          <a:p>
-            <a:pPr marL="190500" indent="-190500">
-              <a:spcBef>
-                <a:spcPts val="400"/>
-              </a:spcBef>
-              <a:spcAft>
-                <a:spcPts val="200"/>
-              </a:spcAft>
-            </a:pPr>
-            <a:r>
-              <a:rPr sz="1300">
-                <a:solidFill>
-                  <a:srgbClr val="3D5466"/>
-                </a:solidFill>
-                <a:latin typeface="Arial"/>
-              </a:rPr>
-              <a:t>▸  MVZ: Spezialisten einbinden (DZ BANK Corporate Finance oder internen gewerblichen Spezialisten) – das ist keine klassische Freiberufler-Finanzierung mehr</a:t>
-            </a:r>
-          </a:p>
-          <a:p>
-            <a:pPr marL="190500" indent="-190500">
-              <a:spcBef>
-                <a:spcPts val="400"/>
-              </a:spcBef>
-              <a:spcAft>
-                <a:spcPts val="200"/>
-              </a:spcAft>
-            </a:pPr>
-            <a:r>
-              <a:rPr sz="1300">
-                <a:solidFill>
-                  <a:srgbClr val="3D5466"/>
-                </a:solidFill>
-                <a:latin typeface="Arial"/>
-              </a:rPr>
-              <a:t>▸  Quelle: Gumpert &amp; Kausch (2022 )</a:t>
-            </a:r>
-          </a:p>
-          <a:p>
-            <a:pPr>
-              <a:spcBef>
-                <a:spcPts val="1000"/>
-              </a:spcBef>
-              <a:spcAft>
-                <a:spcPts val="200"/>
-              </a:spcAft>
-            </a:pPr>
-            <a:r>
-              <a:rPr sz="800" b="1">
-                <a:solidFill>
-                  <a:srgbClr val="78808C"/>
-                </a:solidFill>
-                <a:latin typeface="Consolas"/>
-              </a:rPr>
-              <a:t>EÜR VS. BILANZ: WAS DER BERATER WISSEN MUSS</a:t>
-            </a:r>
-          </a:p>
-          <a:p>
-            <a:pPr marL="190500" indent="-190500">
-              <a:spcBef>
-                <a:spcPts val="400"/>
-              </a:spcBef>
-              <a:spcAft>
-                <a:spcPts val="200"/>
-              </a:spcAft>
-            </a:pPr>
-            <a:r>
-              <a:rPr sz="1300">
-                <a:solidFill>
-                  <a:srgbClr val="3D5466"/>
-                </a:solidFill>
-                <a:latin typeface="Arial"/>
-              </a:rPr>
-              <a:t>▸  Keine Abgrenzung von Anlagevermögen in der EÜR: Investitionen erscheinen als sofortiger Aufwand oder werden über AfA-Listen abgeschrieben; eine bilanzielle Kapitalstruktur fehlt.</a:t>
+              <a:t>▸  Branchenfremde Maßstäbe führen bei Heilberufen systematisch in die Irre.</a:t>
             </a:r>
           </a:p>
         </p:txBody>
@@ -9236,7 +9739,7 @@
                 </a:solidFill>
                 <a:latin typeface="Arial"/>
               </a:rPr>
-              <a:t>Theorie-Input 2: Praxisbewertung und Finanzierungsstruktur</a:t>
+              <a:t>Freie Berufe: rechtliche und wirtschaftliche Grundlagen</a:t>
             </a:r>
           </a:p>
         </p:txBody>
@@ -9258,27 +9761,27 @@
           <a:noFill/>
         </p:spPr>
         <p:txBody>
-          <a:bodyPr wrap="square">
+          <a:bodyPr wrap="square" anchor="ctr">
             <a:spAutoFit/>
           </a:bodyPr>
           <a:lstStyle/>
           <a:p>
-            <a:pPr>
+            <a:pPr marL="177800" indent="-177800">
               <a:spcBef>
-                <a:spcPts val="1000"/>
+                <a:spcPts val="600"/>
               </a:spcBef>
               <a:spcAft>
                 <a:spcPts val="200"/>
               </a:spcAft>
             </a:pPr>
             <a:r>
-              <a:rPr sz="800" b="1">
-                <a:solidFill>
-                  <a:srgbClr val="78808C"/>
-                </a:solidFill>
-                <a:latin typeface="Consolas"/>
-              </a:rPr>
-              <a:t>PRAXISÜBERNAHME VS. PRAXISGRÜNDUNG</a:t>
+              <a:rPr sz="1200" i="1">
+                <a:solidFill>
+                  <a:srgbClr val="3D5466"/>
+                </a:solidFill>
+                <a:latin typeface="Arial"/>
+              </a:rPr>
+              <a:t>→  Der Wert einer Praxis liegt im Patientenstamm und der Zulassung – nicht in Maschinen und Grundstücken.</a:t>
             </a:r>
           </a:p>
           <a:p>
@@ -9297,7 +9800,7 @@
                 </a:solidFill>
                 <a:latin typeface="Arial"/>
               </a:rPr>
-              <a:t>▸  Bewertungsverfahren nach IDW S5:</a:t>
+              <a:t>▸  Freier Beruf vs. Gewerbe: eigene rechtliche und steuerliche Logik.</a:t>
             </a:r>
           </a:p>
           <a:p>
@@ -9316,7 +9819,7 @@
                 </a:solidFill>
                 <a:latin typeface="Arial"/>
               </a:rPr>
-              <a:t>▸  Substanzwert: Zeitwert aller materiellen Wirtschaftsgüter (Praxiseinrichtung, Medizintechnik, IT, Vorräte). Dieser Anteil ist relativ unproblematisch zu finanzieren und gut beleihbar.</a:t>
+              <a:t>▸  Einzelpraxis, Berufsausübungsgemeinschaft (BAG) und MVZ mit unterschiedlichem Risikoprofil.</a:t>
             </a:r>
           </a:p>
           <a:p>
@@ -9335,159 +9838,7 @@
                 </a:solidFill>
                 <a:latin typeface="Arial"/>
               </a:rPr>
-              <a:t>▸  ```</a:t>
-            </a:r>
-          </a:p>
-          <a:p>
-            <a:pPr marL="190500" indent="-190500">
-              <a:spcBef>
-                <a:spcPts val="400"/>
-              </a:spcBef>
-              <a:spcAft>
-                <a:spcPts val="200"/>
-              </a:spcAft>
-            </a:pPr>
-            <a:r>
-              <a:rPr sz="1300">
-                <a:solidFill>
-                  <a:srgbClr val="3D5466"/>
-                </a:solidFill>
-                <a:latin typeface="Arial"/>
-              </a:rPr>
-              <a:t>▸  Modifizierte Ertragswertmethode (IDW S5):</a:t>
-            </a:r>
-          </a:p>
-          <a:p>
-            <a:pPr marL="190500" indent="-190500">
-              <a:spcBef>
-                <a:spcPts val="400"/>
-              </a:spcBef>
-              <a:spcAft>
-                <a:spcPts val="200"/>
-              </a:spcAft>
-            </a:pPr>
-            <a:r>
-              <a:rPr sz="1300">
-                <a:solidFill>
-                  <a:srgbClr val="3D5466"/>
-                </a:solidFill>
-                <a:latin typeface="Arial"/>
-              </a:rPr>
-              <a:t>▸  ./. Risikoabschlag (Zulassungsrisiko, Inhaberabhängigkeit) ca. 20–30 %</a:t>
-            </a:r>
-          </a:p>
-          <a:p>
-            <a:pPr marL="190500" indent="-190500">
-              <a:spcBef>
-                <a:spcPts val="400"/>
-              </a:spcBef>
-              <a:spcAft>
-                <a:spcPts val="200"/>
-              </a:spcAft>
-            </a:pPr>
-            <a:r>
-              <a:rPr sz="1300">
-                <a:solidFill>
-                  <a:srgbClr val="3D5466"/>
-                </a:solidFill>
-                <a:latin typeface="Arial"/>
-              </a:rPr>
-              <a:t>▸  × Kapitalisierungsfaktor (ca. 2,0–3,5×, je nach Fach/Lage)</a:t>
-            </a:r>
-          </a:p>
-          <a:p>
-            <a:pPr marL="190500" indent="-190500">
-              <a:spcBef>
-                <a:spcPts val="400"/>
-              </a:spcBef>
-              <a:spcAft>
-                <a:spcPts val="200"/>
-              </a:spcAft>
-            </a:pPr>
-            <a:r>
-              <a:rPr sz="1300">
-                <a:solidFill>
-                  <a:srgbClr val="3D5466"/>
-                </a:solidFill>
-                <a:latin typeface="Arial"/>
-              </a:rPr>
-              <a:t>▸  Praxiswert gesamt = Substanzwert + Goodwill</a:t>
-            </a:r>
-          </a:p>
-          <a:p>
-            <a:pPr marL="190500" indent="-190500">
-              <a:spcBef>
-                <a:spcPts val="400"/>
-              </a:spcBef>
-              <a:spcAft>
-                <a:spcPts val="200"/>
-              </a:spcAft>
-            </a:pPr>
-            <a:r>
-              <a:rPr sz="1300">
-                <a:solidFill>
-                  <a:srgbClr val="3D5466"/>
-                </a:solidFill>
-                <a:latin typeface="Arial"/>
-              </a:rPr>
-              <a:t>▸  ```</a:t>
-            </a:r>
-          </a:p>
-          <a:p>
-            <a:pPr marL="190500" indent="-190500">
-              <a:spcBef>
-                <a:spcPts val="400"/>
-              </a:spcBef>
-              <a:spcAft>
-                <a:spcPts val="200"/>
-              </a:spcAft>
-            </a:pPr>
-            <a:r>
-              <a:rPr sz="1300">
-                <a:solidFill>
-                  <a:srgbClr val="3D5466"/>
-                </a:solidFill>
-                <a:latin typeface="Arial"/>
-              </a:rPr>
-              <a:t>▸  Quelle: IDW S5 (2021 ); Frodl (2019 )</a:t>
-            </a:r>
-          </a:p>
-          <a:p>
-            <a:pPr>
-              <a:spcBef>
-                <a:spcPts val="1000"/>
-              </a:spcBef>
-              <a:spcAft>
-                <a:spcPts val="200"/>
-              </a:spcAft>
-            </a:pPr>
-            <a:r>
-              <a:rPr sz="800" b="1">
-                <a:solidFill>
-                  <a:srgbClr val="78808C"/>
-                </a:solidFill>
-                <a:latin typeface="Consolas"/>
-              </a:rPr>
-              <a:t>TYPISCHE INVESTITIONSANLÄSSE IM ÜBERBLICK</a:t>
-            </a:r>
-          </a:p>
-          <a:p>
-            <a:pPr marL="190500" indent="-190500">
-              <a:spcBef>
-                <a:spcPts val="400"/>
-              </a:spcBef>
-              <a:spcAft>
-                <a:spcPts val="200"/>
-              </a:spcAft>
-            </a:pPr>
-            <a:r>
-              <a:rPr sz="1300">
-                <a:solidFill>
-                  <a:srgbClr val="3D5466"/>
-                </a:solidFill>
-                <a:latin typeface="Arial"/>
-              </a:rPr>
-              <a:t>▸  Medizinische Versorgungszentren (MVZ):</a:t>
+              <a:t>▸  EÜR statt Bilanz, Honorarstrukturen (KV, PKV, Apothekenmarge) prägen die Analyse.</a:t>
             </a:r>
           </a:p>
         </p:txBody>
@@ -9603,7 +9954,7 @@
             <a:avLst/>
           </a:prstGeom>
           <a:solidFill>
-            <a:srgbClr val="FFFFFF"/>
+            <a:srgbClr val="1F2C56"/>
           </a:solidFill>
           <a:ln>
             <a:noFill/>
@@ -9633,57 +9984,14 @@
       </p:sp>
       <p:sp>
         <p:nvSpPr>
-          <p:cNvPr id="3" name="Rectangle 2"/>
-          <p:cNvSpPr/>
-          <p:nvPr/>
-        </p:nvSpPr>
-        <p:spPr>
-          <a:xfrm>
-            <a:off x="0" y="0"/>
-            <a:ext cx="12188952" cy="50292"/>
-          </a:xfrm>
-          <a:prstGeom prst="rect">
-            <a:avLst/>
-          </a:prstGeom>
-          <a:solidFill>
-            <a:srgbClr val="1F2C56"/>
-          </a:solidFill>
-          <a:ln>
-            <a:noFill/>
-          </a:ln>
-        </p:spPr>
-        <p:style>
-          <a:lnRef idx="1">
-            <a:schemeClr val="accent1"/>
-          </a:lnRef>
-          <a:fillRef idx="3">
-            <a:schemeClr val="accent1"/>
-          </a:fillRef>
-          <a:effectRef idx="2">
-            <a:schemeClr val="accent1"/>
-          </a:effectRef>
-          <a:fontRef idx="minor">
-            <a:schemeClr val="lt1"/>
-          </a:fontRef>
-        </p:style>
-        <p:txBody>
-          <a:bodyPr rtlCol="0" anchor="ctr"/>
-          <a:lstStyle/>
-          <a:p>
-            <a:pPr algn="ctr"/>
-          </a:p>
-        </p:txBody>
-      </p:sp>
-      <p:sp>
-        <p:nvSpPr>
-          <p:cNvPr id="4" name="TextBox 3"/>
+          <p:cNvPr id="3" name="TextBox 2"/>
           <p:cNvSpPr txBox="1"/>
           <p:nvPr/>
         </p:nvSpPr>
         <p:spPr>
           <a:xfrm>
-            <a:off x="685800" y="109728"/>
-            <a:ext cx="10817352" cy="228600"/>
+            <a:off x="685800" y="2377440"/>
+            <a:ext cx="10817352" cy="365760"/>
           </a:xfrm>
           <a:prstGeom prst="rect">
             <a:avLst/>
@@ -9698,62 +10006,27 @@
           <a:p>
             <a:pPr algn="l"/>
             <a:r>
-              <a:rPr sz="750">
-                <a:solidFill>
-                  <a:srgbClr val="78808C"/>
+              <a:rPr sz="1200">
+                <a:solidFill>
+                  <a:srgbClr val="D9C089"/>
                 </a:solidFill>
                 <a:latin typeface="Consolas"/>
               </a:rPr>
-              <a:t>M07  ·  SCHAUBILD</a:t>
-            </a:r>
-          </a:p>
-        </p:txBody>
-      </p:sp>
-      <p:sp>
-        <p:nvSpPr>
-          <p:cNvPr id="5" name="TextBox 4"/>
-          <p:cNvSpPr txBox="1"/>
-          <p:nvPr/>
-        </p:nvSpPr>
-        <p:spPr>
-          <a:xfrm>
-            <a:off x="685800" y="502920"/>
-            <a:ext cx="10817352" cy="594360"/>
-          </a:xfrm>
-          <a:prstGeom prst="rect">
-            <a:avLst/>
-          </a:prstGeom>
-          <a:noFill/>
-        </p:spPr>
-        <p:txBody>
-          <a:bodyPr wrap="square">
-            <a:spAutoFit/>
-          </a:bodyPr>
-          <a:lstStyle/>
-          <a:p>
-            <a:pPr algn="l"/>
-            <a:r>
-              <a:rPr sz="2000" b="1" i="0">
-                <a:solidFill>
-                  <a:srgbClr val="1F2C56"/>
-                </a:solidFill>
-                <a:latin typeface="Arial"/>
-              </a:rPr>
-              <a:t>Praxiswert-Ermittlung nach IDW S5</a:t>
-            </a:r>
-          </a:p>
-        </p:txBody>
-      </p:sp>
-      <p:sp>
-        <p:nvSpPr>
-          <p:cNvPr id="6" name="Rectangle 5"/>
+              <a:t>BEWERTUNG</a:t>
+            </a:r>
+          </a:p>
+        </p:txBody>
+      </p:sp>
+      <p:sp>
+        <p:nvSpPr>
+          <p:cNvPr id="4" name="Rectangle 3"/>
           <p:cNvSpPr/>
           <p:nvPr/>
         </p:nvSpPr>
         <p:spPr>
           <a:xfrm>
-            <a:off x="685800" y="1143000"/>
-            <a:ext cx="10817352" cy="25400"/>
+            <a:off x="685800" y="2788920"/>
+            <a:ext cx="548640" cy="38100"/>
           </a:xfrm>
           <a:prstGeom prst="rect">
             <a:avLst/>
@@ -9787,83 +10060,86 @@
           </a:p>
         </p:txBody>
       </p:sp>
-      <p:pic>
-        <p:nvPicPr>
-          <p:cNvPr id="7" name="Picture 6" descr="image.png"/>
-          <p:cNvPicPr>
-            <a:picLocks noChangeAspect="1"/>
-          </p:cNvPicPr>
-          <p:nvPr/>
-        </p:nvPicPr>
-        <p:blipFill>
-          <a:blip r:embed="rId2"/>
-          <a:stretch>
-            <a:fillRect/>
-          </a:stretch>
-        </p:blipFill>
-        <p:spPr>
-          <a:xfrm>
-            <a:off x="2303489" y="1325880"/>
-            <a:ext cx="7581973" cy="4937760"/>
-          </a:xfrm>
-          <a:prstGeom prst="rect">
-            <a:avLst/>
-          </a:prstGeom>
-        </p:spPr>
-      </p:pic>
-      <p:sp>
-        <p:nvSpPr>
-          <p:cNvPr id="8" name="Rectangle 7"/>
-          <p:cNvSpPr/>
-          <p:nvPr/>
-        </p:nvSpPr>
-        <p:spPr>
-          <a:xfrm>
-            <a:off x="0" y="6510528"/>
-            <a:ext cx="12188952" cy="347472"/>
-          </a:xfrm>
-          <a:prstGeom prst="rect">
-            <a:avLst/>
-          </a:prstGeom>
-          <a:solidFill>
-            <a:srgbClr val="0A1937"/>
-          </a:solidFill>
-          <a:ln>
-            <a:noFill/>
-          </a:ln>
-        </p:spPr>
-        <p:style>
-          <a:lnRef idx="1">
-            <a:schemeClr val="accent1"/>
-          </a:lnRef>
-          <a:fillRef idx="3">
-            <a:schemeClr val="accent1"/>
-          </a:fillRef>
-          <a:effectRef idx="2">
-            <a:schemeClr val="accent1"/>
-          </a:effectRef>
-          <a:fontRef idx="minor">
-            <a:schemeClr val="lt1"/>
-          </a:fontRef>
-        </p:style>
-        <p:txBody>
-          <a:bodyPr rtlCol="0" anchor="ctr"/>
-          <a:lstStyle/>
-          <a:p>
-            <a:pPr algn="ctr"/>
-          </a:p>
-        </p:txBody>
-      </p:sp>
-      <p:sp>
-        <p:nvSpPr>
-          <p:cNvPr id="9" name="TextBox 8"/>
+      <p:sp>
+        <p:nvSpPr>
+          <p:cNvPr id="5" name="TextBox 4"/>
           <p:cNvSpPr txBox="1"/>
           <p:nvPr/>
         </p:nvSpPr>
         <p:spPr>
           <a:xfrm>
-            <a:off x="685800" y="6583680"/>
-            <a:ext cx="6490411" cy="256032"/>
+            <a:off x="685800" y="3017520"/>
+            <a:ext cx="10817352" cy="1463040"/>
+          </a:xfrm>
+          <a:prstGeom prst="rect">
+            <a:avLst/>
+          </a:prstGeom>
+          <a:noFill/>
+        </p:spPr>
+        <p:txBody>
+          <a:bodyPr wrap="square">
+            <a:spAutoFit/>
+          </a:bodyPr>
+          <a:lstStyle/>
+          <a:p>
+            <a:pPr algn="l"/>
+            <a:r>
+              <a:rPr sz="4000" b="1" i="0">
+                <a:solidFill>
+                  <a:srgbClr val="FFFFFF"/>
+                </a:solidFill>
+                <a:latin typeface="Arial"/>
+              </a:rPr>
+              <a:t>Praxisbewertung nach IDW S5</a:t>
+            </a:r>
+          </a:p>
+        </p:txBody>
+      </p:sp>
+      <p:sp>
+        <p:nvSpPr>
+          <p:cNvPr id="6" name="TextBox 5"/>
+          <p:cNvSpPr txBox="1"/>
+          <p:nvPr/>
+        </p:nvSpPr>
+        <p:spPr>
+          <a:xfrm>
+            <a:off x="685800" y="4480560"/>
+            <a:ext cx="8653881" cy="1280160"/>
+          </a:xfrm>
+          <a:prstGeom prst="rect">
+            <a:avLst/>
+          </a:prstGeom>
+          <a:noFill/>
+        </p:spPr>
+        <p:txBody>
+          <a:bodyPr wrap="square">
+            <a:spAutoFit/>
+          </a:bodyPr>
+          <a:lstStyle/>
+          <a:p>
+            <a:pPr algn="l"/>
+            <a:r>
+              <a:rPr sz="1600" b="0" i="0">
+                <a:solidFill>
+                  <a:srgbClr val="C8D2E6"/>
+                </a:solidFill>
+                <a:latin typeface="Arial"/>
+              </a:rPr>
+              <a:t>Den Praxiswert korrekt ermitteln – Goodwill und Substanzwert trennen.</a:t>
+            </a:r>
+          </a:p>
+        </p:txBody>
+      </p:sp>
+      <p:sp>
+        <p:nvSpPr>
+          <p:cNvPr id="7" name="TextBox 6"/>
+          <p:cNvSpPr txBox="1"/>
+          <p:nvPr/>
+        </p:nvSpPr>
+        <p:spPr>
+          <a:xfrm>
+            <a:off x="685800" y="6355080"/>
+            <a:ext cx="10817352" cy="274320"/>
           </a:xfrm>
           <a:prstGeom prst="rect">
             <a:avLst/>
@@ -9880,46 +10156,11 @@
             <a:r>
               <a:rPr sz="700">
                 <a:solidFill>
-                  <a:srgbClr val="A0B4D2"/>
+                  <a:srgbClr val="8CA0C3"/>
                 </a:solidFill>
                 <a:latin typeface="Consolas"/>
               </a:rPr>
               <a:t>FKB Campus  ·  M07</a:t>
-            </a:r>
-          </a:p>
-        </p:txBody>
-      </p:sp>
-      <p:sp>
-        <p:nvSpPr>
-          <p:cNvPr id="10" name="TextBox 9"/>
-          <p:cNvSpPr txBox="1"/>
-          <p:nvPr/>
-        </p:nvSpPr>
-        <p:spPr>
-          <a:xfrm>
-            <a:off x="7176211" y="6583680"/>
-            <a:ext cx="4326940" cy="256032"/>
-          </a:xfrm>
-          <a:prstGeom prst="rect">
-            <a:avLst/>
-          </a:prstGeom>
-          <a:noFill/>
-        </p:spPr>
-        <p:txBody>
-          <a:bodyPr wrap="none">
-            <a:spAutoFit/>
-          </a:bodyPr>
-          <a:lstStyle/>
-          <a:p>
-            <a:pPr algn="r"/>
-            <a:r>
-              <a:rPr sz="700">
-                <a:solidFill>
-                  <a:srgbClr val="A0B4D2"/>
-                </a:solidFill>
-                <a:latin typeface="Consolas"/>
-              </a:rPr>
-              <a:t>Schaubild</a:t>
             </a:r>
           </a:p>
         </p:txBody>
@@ -10179,7 +10420,7 @@
                 </a:solidFill>
                 <a:latin typeface="Arial"/>
               </a:rPr>
-              <a:t>Theorie-Input 3: Risikoprofil und Sicherheitenkonzept</a:t>
+              <a:t>Praxiswert: Goodwill plus Substanzwert</a:t>
             </a:r>
           </a:p>
         </p:txBody>
@@ -10201,27 +10442,27 @@
           <a:noFill/>
         </p:spPr>
         <p:txBody>
-          <a:bodyPr wrap="square">
+          <a:bodyPr wrap="square" anchor="ctr">
             <a:spAutoFit/>
           </a:bodyPr>
           <a:lstStyle/>
           <a:p>
-            <a:pPr>
+            <a:pPr marL="177800" indent="-177800">
               <a:spcBef>
-                <a:spcPts val="1000"/>
+                <a:spcPts val="600"/>
               </a:spcBef>
               <a:spcAft>
                 <a:spcPts val="200"/>
               </a:spcAft>
             </a:pPr>
             <a:r>
-              <a:rPr sz="800" b="1">
-                <a:solidFill>
-                  <a:srgbClr val="78808C"/>
-                </a:solidFill>
-                <a:latin typeface="Consolas"/>
-              </a:rPr>
-              <a:t>SPEZIFISCHE RISIKEN BEI HEILBERUFE-KUNDEN</a:t>
+              <a:rPr sz="1200" i="1">
+                <a:solidFill>
+                  <a:srgbClr val="3D5466"/>
+                </a:solidFill>
+                <a:latin typeface="Arial"/>
+              </a:rPr>
+              <a:t>→  Der Praxiswert ist überwiegend Goodwill – der ideelle Wert aus Patientenstamm, Standort und Ruf.</a:t>
             </a:r>
           </a:p>
           <a:p>
@@ -10240,7 +10481,7 @@
                 </a:solidFill>
                 <a:latin typeface="Arial"/>
               </a:rPr>
-              <a:t>▸  Zulassungsrisiko:</a:t>
+              <a:t>▸  Modifizierte Ertragswertmethode (IDW S5): nachhaltiger Gewinn minus Unternehmerlohn, kapitalisiert.</a:t>
             </a:r>
           </a:p>
           <a:p>
@@ -10259,178 +10500,7 @@
                 </a:solidFill>
                 <a:latin typeface="Arial"/>
               </a:rPr>
-              <a:t>▸  Kassenarztzulassung und ihre Übertragbarkeit in der Nachfolge:</a:t>
-            </a:r>
-          </a:p>
-          <a:p>
-            <a:pPr marL="190500" indent="-190500">
-              <a:spcBef>
-                <a:spcPts val="400"/>
-              </a:spcBef>
-              <a:spcAft>
-                <a:spcPts val="200"/>
-              </a:spcAft>
-            </a:pPr>
-            <a:r>
-              <a:rPr sz="1300">
-                <a:solidFill>
-                  <a:srgbClr val="3D5466"/>
-                </a:solidFill>
-                <a:latin typeface="Arial"/>
-              </a:rPr>
-              <a:t>▸  Regressrisiko:</a:t>
-            </a:r>
-          </a:p>
-          <a:p>
-            <a:pPr marL="190500" indent="-190500">
-              <a:spcBef>
-                <a:spcPts val="400"/>
-              </a:spcBef>
-              <a:spcAft>
-                <a:spcPts val="200"/>
-              </a:spcAft>
-            </a:pPr>
-            <a:r>
-              <a:rPr sz="1300">
-                <a:solidFill>
-                  <a:srgbClr val="3D5466"/>
-                </a:solidFill>
-                <a:latin typeface="Arial"/>
-              </a:rPr>
-              <a:t>▸  Inhaberabhängigkeit:</a:t>
-            </a:r>
-          </a:p>
-          <a:p>
-            <a:pPr marL="190500" indent="-190500">
-              <a:spcBef>
-                <a:spcPts val="400"/>
-              </a:spcBef>
-              <a:spcAft>
-                <a:spcPts val="200"/>
-              </a:spcAft>
-            </a:pPr>
-            <a:r>
-              <a:rPr sz="1300">
-                <a:solidFill>
-                  <a:srgbClr val="3D5466"/>
-                </a:solidFill>
-                <a:latin typeface="Arial"/>
-              </a:rPr>
-              <a:t>▸  Versorgungswerk statt gesetzliche Rentenversicherung:</a:t>
-            </a:r>
-          </a:p>
-          <a:p>
-            <a:pPr marL="190500" indent="-190500">
-              <a:spcBef>
-                <a:spcPts val="400"/>
-              </a:spcBef>
-              <a:spcAft>
-                <a:spcPts val="200"/>
-              </a:spcAft>
-            </a:pPr>
-            <a:r>
-              <a:rPr sz="1300">
-                <a:solidFill>
-                  <a:srgbClr val="3D5466"/>
-                </a:solidFill>
-                <a:latin typeface="Arial"/>
-              </a:rPr>
-              <a:t>▸  Strukturrisiko MVZ-Konsolidierung:</a:t>
-            </a:r>
-          </a:p>
-          <a:p>
-            <a:pPr>
-              <a:spcBef>
-                <a:spcPts val="1000"/>
-              </a:spcBef>
-              <a:spcAft>
-                <a:spcPts val="200"/>
-              </a:spcAft>
-            </a:pPr>
-            <a:r>
-              <a:rPr sz="800" b="1">
-                <a:solidFill>
-                  <a:srgbClr val="78808C"/>
-                </a:solidFill>
-                <a:latin typeface="Consolas"/>
-              </a:rPr>
-              <a:t>SICHERHEITENKONZEPT BEI HEILBERUFE-FINANZIERUNGEN</a:t>
-            </a:r>
-          </a:p>
-          <a:p>
-            <a:pPr marL="190500" indent="-190500">
-              <a:spcBef>
-                <a:spcPts val="400"/>
-              </a:spcBef>
-              <a:spcAft>
-                <a:spcPts val="200"/>
-              </a:spcAft>
-            </a:pPr>
-            <a:r>
-              <a:rPr sz="1300">
-                <a:solidFill>
-                  <a:srgbClr val="3D5466"/>
-                </a:solidFill>
-                <a:latin typeface="Arial"/>
-              </a:rPr>
-              <a:t>▸  § 18 KWG (Offenlegungspflicht ab 750.000 EUR Kreditbetrag) ist zu beachten. Die gesamtschuldnerische Bonitätsanalyse bei Praxisübernahmen folgt MaRisk BTO 1.2.1 .</a:t>
-            </a:r>
-          </a:p>
-          <a:p>
-            <a:pPr>
-              <a:spcBef>
-                <a:spcPts val="1000"/>
-              </a:spcBef>
-              <a:spcAft>
-                <a:spcPts val="200"/>
-              </a:spcAft>
-            </a:pPr>
-            <a:r>
-              <a:rPr sz="800" b="1">
-                <a:solidFill>
-                  <a:srgbClr val="78808C"/>
-                </a:solidFill>
-                <a:latin typeface="Consolas"/>
-              </a:rPr>
-              <a:t>VERBUNDPARTNER SCHWÄBISCH HALL: PRAXISIMMOBILIEN UND TILGUNGSAUSSETZUNGSMODELL</a:t>
-            </a:r>
-          </a:p>
-          <a:p>
-            <a:pPr marL="190500" indent="-190500">
-              <a:spcBef>
-                <a:spcPts val="400"/>
-              </a:spcBef>
-              <a:spcAft>
-                <a:spcPts val="200"/>
-              </a:spcAft>
-            </a:pPr>
-            <a:r>
-              <a:rPr sz="1300">
-                <a:solidFill>
-                  <a:srgbClr val="3D5466"/>
-                </a:solidFill>
-                <a:latin typeface="Arial"/>
-              </a:rPr>
-              <a:t>▸  Das Tilgungsaussetzungsmodell (Vorfinanzierung mit Bausparvertrag):</a:t>
-            </a:r>
-          </a:p>
-          <a:p>
-            <a:pPr marL="190500" indent="-190500">
-              <a:spcBef>
-                <a:spcPts val="400"/>
-              </a:spcBef>
-              <a:spcAft>
-                <a:spcPts val="200"/>
-              </a:spcAft>
-            </a:pPr>
-            <a:r>
-              <a:rPr sz="1300">
-                <a:solidFill>
-                  <a:srgbClr val="3D5466"/>
-                </a:solidFill>
-                <a:latin typeface="Arial"/>
-              </a:rPr>
-              <a:t>▸  Vorteile für den Kunden:</a:t>
+              <a:t>▸  Goodwill plus Substanzwert (Geräte, Einrichtung) ergibt den Praxiswert.</a:t>
             </a:r>
           </a:p>
         </p:txBody>
@@ -10682,7 +10752,7 @@
                 </a:solidFill>
                 <a:latin typeface="Arial"/>
               </a:rPr>
-              <a:t>Handlungsempfehlung Heilberufe</a:t>
+              <a:t>Praxiswert-Ermittlung nach IDW S5</a:t>
             </a:r>
           </a:p>
         </p:txBody>

</xml_diff>